<commit_message>
Add 2D figure-eight experiment and update presentation with results
- New imitations_2d/ folder: 2D trajectory tracking with Lissajous target
  (441 states, 9 actions, 3969 Q-table entries)
- Dropout-Aware beats Naive by 15.5% at eval (0.3730 vs 0.4413 error)
- Fixed baseline eval to use no dropout (upper bound with perfect info)
- Added 5 slides to presentation: transition, 2D setup, trajectories,
  results, and 1D vs 2D comparison

Co-Authored-By: Claude Opus 4.6 <noreply@anthropic.com>
</commit_message>
<xml_diff>
--- a/imitations/presentation.pptx
+++ b/imitations/presentation.pptx
@@ -25,6 +25,11 @@
     <p:sldId id="273" r:id="rId24"/>
     <p:sldId id="274" r:id="rId25"/>
     <p:sldId id="275" r:id="rId26"/>
+    <p:sldId id="276" r:id="rId27"/>
+    <p:sldId id="277" r:id="rId28"/>
+    <p:sldId id="278" r:id="rId29"/>
+    <p:sldId id="279" r:id="rId30"/>
+    <p:sldId id="280" r:id="rId31"/>
   </p:sldIdLst>
   <p:sldSz cx="12191695" cy="6858000" type="screen4x3"/>
   <p:notesSz cx="6858000" cy="9144000"/>
@@ -7033,8 +7038,8 @@
         </p:nvSpPr>
         <p:spPr>
           <a:xfrm>
-            <a:off x="731520" y="274320"/>
-            <a:ext cx="10515600" cy="731520"/>
+            <a:off x="914400" y="914400"/>
+            <a:ext cx="10058400" cy="1371600"/>
           </a:xfrm>
           <a:prstGeom prst="rect">
             <a:avLst/>
@@ -7053,80 +7058,27 @@
               </a:lnSpc>
               <a:defRPr sz="4400" b="1">
                 <a:solidFill>
-                  <a:srgbClr val="FFFFFF"/>
-                </a:solidFill>
-                <a:latin typeface="Calibri"/>
-              </a:defRPr>
-            </a:pPr>
-            <a:r>
-              <a:t>Three Takeaways</a:t>
-            </a:r>
-          </a:p>
-        </p:txBody>
-      </p:sp>
-      <p:sp>
-        <p:nvSpPr>
-          <p:cNvPr id="3" name="Rounded Rectangle 2"/>
-          <p:cNvSpPr/>
-          <p:nvPr/>
-        </p:nvSpPr>
-        <p:spPr>
-          <a:xfrm>
-            <a:off x="914400" y="1371600"/>
-            <a:ext cx="731520" cy="731520"/>
-          </a:xfrm>
-          <a:prstGeom prst="roundRect">
-            <a:avLst/>
-          </a:prstGeom>
-          <a:solidFill>
-            <a:srgbClr val="4EC98B"/>
-          </a:solidFill>
-          <a:ln>
-            <a:noFill/>
-          </a:ln>
-        </p:spPr>
-        <p:style>
-          <a:lnRef idx="1">
-            <a:schemeClr val="accent1"/>
-          </a:lnRef>
-          <a:fillRef idx="3">
-            <a:schemeClr val="accent1"/>
-          </a:fillRef>
-          <a:effectRef idx="2">
-            <a:schemeClr val="accent1"/>
-          </a:effectRef>
-          <a:fontRef idx="minor">
-            <a:schemeClr val="lt1"/>
-          </a:fontRef>
-        </p:style>
-        <p:txBody>
-          <a:bodyPr rtlCol="0" anchor="ctr" wrap="square"/>
-          <a:lstStyle/>
-          <a:p>
-            <a:pPr algn="ctr">
-              <a:defRPr sz="3200" b="1">
-                <a:solidFill>
-                  <a:srgbClr val="1A1A2E"/>
-                </a:solidFill>
-                <a:latin typeface="Calibri"/>
-              </a:defRPr>
-            </a:pPr>
-            <a:r>
-              <a:t>1</a:t>
-            </a:r>
-          </a:p>
-        </p:txBody>
-      </p:sp>
-      <p:sp>
-        <p:nvSpPr>
-          <p:cNvPr id="4" name="TextBox 3"/>
+                  <a:srgbClr val="F5C542"/>
+                </a:solidFill>
+                <a:latin typeface="Calibri"/>
+              </a:defRPr>
+            </a:pPr>
+            <a:r>
+              <a:t>But was our problem too easy?</a:t>
+            </a:r>
+          </a:p>
+        </p:txBody>
+      </p:sp>
+      <p:sp>
+        <p:nvSpPr>
+          <p:cNvPr id="3" name="TextBox 2"/>
           <p:cNvSpPr txBox="1"/>
           <p:nvPr/>
         </p:nvSpPr>
         <p:spPr>
           <a:xfrm>
-            <a:off x="1920240" y="1371600"/>
-            <a:ext cx="9144000" cy="548640"/>
+            <a:off x="1371600" y="2743200"/>
+            <a:ext cx="9144000" cy="3200400"/>
           </a:xfrm>
           <a:prstGeom prst="rect">
             <a:avLst/>
@@ -7139,332 +7091,89 @@
           </a:bodyPr>
           <a:lstStyle/>
           <a:p>
+            <a:pPr algn="ctr">
+              <a:lnSpc>
+                <a:spcPts val="3100"/>
+              </a:lnSpc>
+              <a:defRPr sz="2600" b="0">
+                <a:solidFill>
+                  <a:srgbClr val="FFFFFF"/>
+                </a:solidFill>
+                <a:latin typeface="Calibri"/>
+              </a:defRPr>
+            </a:pPr>
+            <a:r>
+              <a:t>In 1D, Naive and Dropout-Aware converged to the same policy.</a:t>
+            </a:r>
+          </a:p>
+          <a:p>
             <a:pPr algn="l">
               <a:lnSpc>
-                <a:spcPts val="3300"/>
-              </a:lnSpc>
-              <a:defRPr sz="2800" b="1">
-                <a:solidFill>
-                  <a:srgbClr val="4EC98B"/>
-                </a:solidFill>
-                <a:latin typeface="Calibri"/>
-              </a:defRPr>
-            </a:pPr>
-            <a:r>
-              <a:t>When in doubt, don't act.</a:t>
-            </a:r>
-          </a:p>
-        </p:txBody>
-      </p:sp>
-      <p:sp>
-        <p:nvSpPr>
-          <p:cNvPr id="5" name="TextBox 4"/>
-          <p:cNvSpPr txBox="1"/>
-          <p:nvPr/>
-        </p:nvSpPr>
-        <p:spPr>
-          <a:xfrm>
-            <a:off x="1920240" y="2011680"/>
-            <a:ext cx="9144000" cy="914400"/>
-          </a:xfrm>
-          <a:prstGeom prst="rect">
-            <a:avLst/>
-          </a:prstGeom>
-          <a:noFill/>
-        </p:spPr>
-        <p:txBody>
-          <a:bodyPr wrap="square">
-            <a:spAutoFit/>
-          </a:bodyPr>
-          <a:lstStyle/>
+                <a:spcPts val="1200"/>
+              </a:lnSpc>
+              <a:spcBef>
+                <a:spcPts val="0"/>
+              </a:spcBef>
+              <a:defRPr sz="1000" b="0">
+                <a:solidFill>
+                  <a:srgbClr val="FFFFFF"/>
+                </a:solidFill>
+                <a:latin typeface="Calibri"/>
+              </a:defRPr>
+            </a:pPr>
+          </a:p>
+          <a:p>
+            <a:pPr algn="ctr">
+              <a:lnSpc>
+                <a:spcPts val="2800"/>
+              </a:lnSpc>
+              <a:spcBef>
+                <a:spcPts val="1200"/>
+              </a:spcBef>
+              <a:defRPr sz="2400" b="0">
+                <a:solidFill>
+                  <a:srgbClr val="CCCCCC"/>
+                </a:solidFill>
+                <a:latin typeface="Calibri"/>
+              </a:defRPr>
+            </a:pPr>
+            <a:r>
+              <a:t>41 states, 3 actions — too simple to corrupt.</a:t>
+            </a:r>
+          </a:p>
           <a:p>
             <a:pPr algn="l">
               <a:lnSpc>
-                <a:spcPts val="2300"/>
-              </a:lnSpc>
-              <a:defRPr sz="1800" b="0">
-                <a:solidFill>
-                  <a:srgbClr val="CCCCCC"/>
-                </a:solidFill>
-                <a:latin typeface="Calibri"/>
-              </a:defRPr>
-            </a:pPr>
-            <a:r>
-              <a:t>Acting on bad information is worse than waiting.</a:t>
-            </a:r>
-            <a:br/>
-            <a:r>
-              <a:t>The dropout-aware agent improved by simply skipping uncertain updates.</a:t>
-            </a:r>
-          </a:p>
-        </p:txBody>
-      </p:sp>
-      <p:sp>
-        <p:nvSpPr>
-          <p:cNvPr id="6" name="Rounded Rectangle 5"/>
-          <p:cNvSpPr/>
-          <p:nvPr/>
-        </p:nvSpPr>
-        <p:spPr>
-          <a:xfrm>
-            <a:off x="914400" y="3108960"/>
-            <a:ext cx="731520" cy="731520"/>
-          </a:xfrm>
-          <a:prstGeom prst="roundRect">
-            <a:avLst/>
-          </a:prstGeom>
-          <a:solidFill>
-            <a:srgbClr val="4D9DE8"/>
-          </a:solidFill>
-          <a:ln>
-            <a:noFill/>
-          </a:ln>
-        </p:spPr>
-        <p:style>
-          <a:lnRef idx="1">
-            <a:schemeClr val="accent1"/>
-          </a:lnRef>
-          <a:fillRef idx="3">
-            <a:schemeClr val="accent1"/>
-          </a:fillRef>
-          <a:effectRef idx="2">
-            <a:schemeClr val="accent1"/>
-          </a:effectRef>
-          <a:fontRef idx="minor">
-            <a:schemeClr val="lt1"/>
-          </a:fontRef>
-        </p:style>
-        <p:txBody>
-          <a:bodyPr rtlCol="0" anchor="ctr" wrap="square"/>
-          <a:lstStyle/>
+                <a:spcPts val="1200"/>
+              </a:lnSpc>
+              <a:spcBef>
+                <a:spcPts val="0"/>
+              </a:spcBef>
+              <a:defRPr sz="1000" b="0">
+                <a:solidFill>
+                  <a:srgbClr val="FFFFFF"/>
+                </a:solidFill>
+                <a:latin typeface="Calibri"/>
+              </a:defRPr>
+            </a:pPr>
+          </a:p>
           <a:p>
             <a:pPr algn="ctr">
-              <a:defRPr sz="3200" b="1">
-                <a:solidFill>
-                  <a:srgbClr val="1A1A2E"/>
-                </a:solidFill>
-                <a:latin typeface="Calibri"/>
-              </a:defRPr>
-            </a:pPr>
-            <a:r>
-              <a:t>2</a:t>
-            </a:r>
-          </a:p>
-        </p:txBody>
-      </p:sp>
-      <p:sp>
-        <p:nvSpPr>
-          <p:cNvPr id="7" name="TextBox 6"/>
-          <p:cNvSpPr txBox="1"/>
-          <p:nvPr/>
-        </p:nvSpPr>
-        <p:spPr>
-          <a:xfrm>
-            <a:off x="1920240" y="3108960"/>
-            <a:ext cx="9144000" cy="548640"/>
-          </a:xfrm>
-          <a:prstGeom prst="rect">
-            <a:avLst/>
-          </a:prstGeom>
-          <a:noFill/>
-        </p:spPr>
-        <p:txBody>
-          <a:bodyPr wrap="square">
-            <a:spAutoFit/>
-          </a:bodyPr>
-          <a:lstStyle/>
-          <a:p>
-            <a:pPr algn="l">
-              <a:lnSpc>
-                <a:spcPts val="3300"/>
-              </a:lnSpc>
-              <a:defRPr sz="2800" b="1">
-                <a:solidFill>
-                  <a:srgbClr val="4D9DE8"/>
-                </a:solidFill>
-                <a:latin typeface="Calibri"/>
-              </a:defRPr>
-            </a:pPr>
-            <a:r>
-              <a:t>Simple beats clever.</a:t>
-            </a:r>
-          </a:p>
-        </p:txBody>
-      </p:sp>
-      <p:sp>
-        <p:nvSpPr>
-          <p:cNvPr id="8" name="TextBox 7"/>
-          <p:cNvSpPr txBox="1"/>
-          <p:nvPr/>
-        </p:nvSpPr>
-        <p:spPr>
-          <a:xfrm>
-            <a:off x="1920240" y="3749040"/>
-            <a:ext cx="9144000" cy="914400"/>
-          </a:xfrm>
-          <a:prstGeom prst="rect">
-            <a:avLst/>
-          </a:prstGeom>
-          <a:noFill/>
-        </p:spPr>
-        <p:txBody>
-          <a:bodyPr wrap="square">
-            <a:spAutoFit/>
-          </a:bodyPr>
-          <a:lstStyle/>
-          <a:p>
-            <a:pPr algn="l">
-              <a:lnSpc>
-                <a:spcPts val="2300"/>
-              </a:lnSpc>
-              <a:defRPr sz="1800" b="0">
-                <a:solidFill>
-                  <a:srgbClr val="CCCCCC"/>
-                </a:solidFill>
-                <a:latin typeface="Calibri"/>
-              </a:defRPr>
-            </a:pPr>
-            <a:r>
-              <a:t>A sophisticated state estimator made things worse.</a:t>
-            </a:r>
-            <a:br/>
-            <a:r>
-              <a:t>The best strategy was the most obvious one.</a:t>
-            </a:r>
-          </a:p>
-        </p:txBody>
-      </p:sp>
-      <p:sp>
-        <p:nvSpPr>
-          <p:cNvPr id="9" name="Rounded Rectangle 8"/>
-          <p:cNvSpPr/>
-          <p:nvPr/>
-        </p:nvSpPr>
-        <p:spPr>
-          <a:xfrm>
-            <a:off x="914400" y="4846320"/>
-            <a:ext cx="731520" cy="731520"/>
-          </a:xfrm>
-          <a:prstGeom prst="roundRect">
-            <a:avLst/>
-          </a:prstGeom>
-          <a:solidFill>
-            <a:srgbClr val="F08C3A"/>
-          </a:solidFill>
-          <a:ln>
-            <a:noFill/>
-          </a:ln>
-        </p:spPr>
-        <p:style>
-          <a:lnRef idx="1">
-            <a:schemeClr val="accent1"/>
-          </a:lnRef>
-          <a:fillRef idx="3">
-            <a:schemeClr val="accent1"/>
-          </a:fillRef>
-          <a:effectRef idx="2">
-            <a:schemeClr val="accent1"/>
-          </a:effectRef>
-          <a:fontRef idx="minor">
-            <a:schemeClr val="lt1"/>
-          </a:fontRef>
-        </p:style>
-        <p:txBody>
-          <a:bodyPr rtlCol="0" anchor="ctr" wrap="square"/>
-          <a:lstStyle/>
-          <a:p>
-            <a:pPr algn="ctr">
-              <a:defRPr sz="3200" b="1">
-                <a:solidFill>
-                  <a:srgbClr val="1A1A2E"/>
-                </a:solidFill>
-                <a:latin typeface="Calibri"/>
-              </a:defRPr>
-            </a:pPr>
-            <a:r>
-              <a:t>3</a:t>
-            </a:r>
-          </a:p>
-        </p:txBody>
-      </p:sp>
-      <p:sp>
-        <p:nvSpPr>
-          <p:cNvPr id="10" name="TextBox 9"/>
-          <p:cNvSpPr txBox="1"/>
-          <p:nvPr/>
-        </p:nvSpPr>
-        <p:spPr>
-          <a:xfrm>
-            <a:off x="1920240" y="4846320"/>
-            <a:ext cx="9144000" cy="548640"/>
-          </a:xfrm>
-          <a:prstGeom prst="rect">
-            <a:avLst/>
-          </a:prstGeom>
-          <a:noFill/>
-        </p:spPr>
-        <p:txBody>
-          <a:bodyPr wrap="square">
-            <a:spAutoFit/>
-          </a:bodyPr>
-          <a:lstStyle/>
-          <a:p>
-            <a:pPr algn="l">
-              <a:lnSpc>
-                <a:spcPts val="3300"/>
-              </a:lnSpc>
-              <a:defRPr sz="2800" b="1">
-                <a:solidFill>
-                  <a:srgbClr val="F08C3A"/>
-                </a:solidFill>
-                <a:latin typeface="Calibri"/>
-              </a:defRPr>
-            </a:pPr>
-            <a:r>
-              <a:t>You don't need to define the goal.</a:t>
-            </a:r>
-          </a:p>
-        </p:txBody>
-      </p:sp>
-      <p:sp>
-        <p:nvSpPr>
-          <p:cNvPr id="11" name="TextBox 10"/>
-          <p:cNvSpPr txBox="1"/>
-          <p:nvPr/>
-        </p:nvSpPr>
-        <p:spPr>
-          <a:xfrm>
-            <a:off x="1920240" y="5486400"/>
-            <a:ext cx="9144000" cy="914400"/>
-          </a:xfrm>
-          <a:prstGeom prst="rect">
-            <a:avLst/>
-          </a:prstGeom>
-          <a:noFill/>
-        </p:spPr>
-        <p:txBody>
-          <a:bodyPr wrap="square">
-            <a:spAutoFit/>
-          </a:bodyPr>
-          <a:lstStyle/>
-          <a:p>
-            <a:pPr algn="l">
-              <a:lnSpc>
-                <a:spcPts val="2300"/>
-              </a:lnSpc>
-              <a:defRPr sz="1800" b="0">
-                <a:solidFill>
-                  <a:srgbClr val="CCCCCC"/>
-                </a:solidFill>
-                <a:latin typeface="Calibri"/>
-              </a:defRPr>
-            </a:pPr>
-            <a:r>
-              <a:t>Inverse RL discovered the reward from expert demonstrations alone.</a:t>
-            </a:r>
-            <a:br/>
-            <a:r>
-              <a:t>The objective reveals itself through behavior.</a:t>
+              <a:lnSpc>
+                <a:spcPts val="3600"/>
+              </a:lnSpc>
+              <a:spcBef>
+                <a:spcPts val="1600"/>
+              </a:spcBef>
+              <a:defRPr sz="3000" b="1">
+                <a:solidFill>
+                  <a:srgbClr val="E84D4D"/>
+                </a:solidFill>
+                <a:latin typeface="Calibri"/>
+              </a:defRPr>
+            </a:pPr>
+            <a:r>
+              <a:t>What happens when we scale up?</a:t>
             </a:r>
           </a:p>
         </p:txBody>
@@ -7503,8 +7212,8 @@
         </p:nvSpPr>
         <p:spPr>
           <a:xfrm>
-            <a:off x="914400" y="914400"/>
-            <a:ext cx="10058400" cy="1828800"/>
+            <a:off x="731520" y="274320"/>
+            <a:ext cx="10058400" cy="731520"/>
           </a:xfrm>
           <a:prstGeom prst="rect">
             <a:avLst/>
@@ -7517,37 +7226,76 @@
           </a:bodyPr>
           <a:lstStyle/>
           <a:p>
-            <a:pPr algn="ctr">
-              <a:lnSpc>
-                <a:spcPts val="5400"/>
-              </a:lnSpc>
-              <a:defRPr sz="3600" b="0">
-                <a:solidFill>
-                  <a:srgbClr val="CCCCCC"/>
-                </a:solidFill>
-                <a:latin typeface="Calibri"/>
-              </a:defRPr>
-            </a:pPr>
-            <a:r>
-              <a:t>The next time a robot loses signal</a:t>
-            </a:r>
-            <a:br/>
-            <a:r>
-              <a:t>mid-operation...</a:t>
-            </a:r>
-          </a:p>
-        </p:txBody>
-      </p:sp>
-      <p:sp>
-        <p:nvSpPr>
-          <p:cNvPr id="3" name="TextBox 2"/>
+            <a:pPr algn="l">
+              <a:lnSpc>
+                <a:spcPts val="4800"/>
+              </a:lnSpc>
+              <a:defRPr sz="4000" b="1">
+                <a:solidFill>
+                  <a:srgbClr val="FFFFFF"/>
+                </a:solidFill>
+                <a:latin typeface="Calibri"/>
+              </a:defRPr>
+            </a:pPr>
+            <a:r>
+              <a:t>Scaling Up: 2D Figure-Eight Tracking</a:t>
+            </a:r>
+          </a:p>
+        </p:txBody>
+      </p:sp>
+      <p:sp>
+        <p:nvSpPr>
+          <p:cNvPr id="3" name="Rounded Rectangle 2"/>
+          <p:cNvSpPr/>
+          <p:nvPr/>
+        </p:nvSpPr>
+        <p:spPr>
+          <a:xfrm>
+            <a:off x="731520" y="1371600"/>
+            <a:ext cx="5029200" cy="4754880"/>
+          </a:xfrm>
+          <a:prstGeom prst="roundRect">
+            <a:avLst/>
+          </a:prstGeom>
+          <a:solidFill>
+            <a:srgbClr val="2A2A45"/>
+          </a:solidFill>
+          <a:ln>
+            <a:noFill/>
+          </a:ln>
+        </p:spPr>
+        <p:style>
+          <a:lnRef idx="1">
+            <a:schemeClr val="accent1"/>
+          </a:lnRef>
+          <a:fillRef idx="3">
+            <a:schemeClr val="accent1"/>
+          </a:fillRef>
+          <a:effectRef idx="2">
+            <a:schemeClr val="accent1"/>
+          </a:effectRef>
+          <a:fontRef idx="minor">
+            <a:schemeClr val="lt1"/>
+          </a:fontRef>
+        </p:style>
+        <p:txBody>
+          <a:bodyPr rtlCol="0" anchor="ctr"/>
+          <a:lstStyle/>
+          <a:p>
+            <a:pPr algn="ctr"/>
+          </a:p>
+        </p:txBody>
+      </p:sp>
+      <p:sp>
+        <p:nvSpPr>
+          <p:cNvPr id="4" name="TextBox 3"/>
           <p:cNvSpPr txBox="1"/>
           <p:nvPr/>
         </p:nvSpPr>
         <p:spPr>
           <a:xfrm>
-            <a:off x="914400" y="2926080"/>
-            <a:ext cx="10058400" cy="2286000"/>
+            <a:off x="914400" y="1463040"/>
+            <a:ext cx="4663440" cy="4572000"/>
           </a:xfrm>
           <a:prstGeom prst="rect">
             <a:avLst/>
@@ -7560,37 +7308,541 @@
           </a:bodyPr>
           <a:lstStyle/>
           <a:p>
-            <a:pPr algn="ctr">
-              <a:lnSpc>
-                <a:spcPts val="5400"/>
-              </a:lnSpc>
-              <a:defRPr sz="3600" b="0">
-                <a:solidFill>
-                  <a:srgbClr val="FFFFFF"/>
-                </a:solidFill>
-                <a:latin typeface="Calibri"/>
-              </a:defRPr>
-            </a:pPr>
-            <a:r>
-              <a:t>the smartest thing it can do</a:t>
-            </a:r>
-            <a:br/>
-            <a:r>
-              <a:t>might be the simplest:</a:t>
-            </a:r>
-          </a:p>
-        </p:txBody>
-      </p:sp>
-      <p:sp>
-        <p:nvSpPr>
-          <p:cNvPr id="4" name="TextBox 3"/>
+            <a:pPr algn="l">
+              <a:lnSpc>
+                <a:spcPts val="2400"/>
+              </a:lnSpc>
+              <a:defRPr sz="2000" b="1">
+                <a:solidFill>
+                  <a:srgbClr val="F5C542"/>
+                </a:solidFill>
+                <a:latin typeface="Calibri"/>
+              </a:defRPr>
+            </a:pPr>
+          </a:p>
+        </p:txBody>
+      </p:sp>
+      <p:graphicFrame>
+        <p:nvGraphicFramePr>
+          <p:cNvPr id="5" name="Table 4"/>
+          <p:cNvGraphicFramePr>
+            <a:graphicFrameLocks noGrp="1"/>
+          </p:cNvGraphicFramePr>
+          <p:nvPr/>
+        </p:nvGraphicFramePr>
+        <p:xfrm>
+          <a:off x="731520" y="1463040"/>
+          <a:ext cx="5029200" cy="3657600"/>
+        </p:xfrm>
+        <a:graphic>
+          <a:graphicData uri="http://schemas.openxmlformats.org/drawingml/2006/table">
+            <a:tbl>
+              <a:tblPr firstRow="1" bandRow="1">
+                <a:tableStyleId>{5C22544A-7EE6-4342-B048-85BDC9FD1C3A}</a:tableStyleId>
+              </a:tblPr>
+              <a:tblGrid>
+                <a:gridCol w="1645920"/>
+                <a:gridCol w="1645920"/>
+                <a:gridCol w="1737360"/>
+              </a:tblGrid>
+              <a:tr h="609600">
+                <a:tc>
+                  <a:txBody>
+                    <a:bodyPr/>
+                    <a:lstStyle/>
+                    <a:p>
+                      <a:pPr algn="ctr">
+                        <a:defRPr sz="1800" b="1">
+                          <a:solidFill>
+                            <a:srgbClr val="F5C542"/>
+                          </a:solidFill>
+                          <a:latin typeface="Calibri"/>
+                        </a:defRPr>
+                      </a:pPr>
+                    </a:p>
+                  </a:txBody>
+                  <a:tcPr>
+                    <a:solidFill>
+                      <a:srgbClr val="333355"/>
+                    </a:solidFill>
+                  </a:tcPr>
+                </a:tc>
+                <a:tc>
+                  <a:txBody>
+                    <a:bodyPr/>
+                    <a:lstStyle/>
+                    <a:p>
+                      <a:pPr algn="ctr">
+                        <a:defRPr sz="1800" b="1">
+                          <a:solidFill>
+                            <a:srgbClr val="F5C542"/>
+                          </a:solidFill>
+                          <a:latin typeface="Calibri"/>
+                        </a:defRPr>
+                      </a:pPr>
+                      <a:r>
+                        <a:t>1D (before)</a:t>
+                      </a:r>
+                    </a:p>
+                  </a:txBody>
+                  <a:tcPr>
+                    <a:solidFill>
+                      <a:srgbClr val="333355"/>
+                    </a:solidFill>
+                  </a:tcPr>
+                </a:tc>
+                <a:tc>
+                  <a:txBody>
+                    <a:bodyPr/>
+                    <a:lstStyle/>
+                    <a:p>
+                      <a:pPr algn="ctr">
+                        <a:defRPr sz="1800" b="1">
+                          <a:solidFill>
+                            <a:srgbClr val="F5C542"/>
+                          </a:solidFill>
+                          <a:latin typeface="Calibri"/>
+                        </a:defRPr>
+                      </a:pPr>
+                      <a:r>
+                        <a:t>2D (now)</a:t>
+                      </a:r>
+                    </a:p>
+                  </a:txBody>
+                  <a:tcPr>
+                    <a:solidFill>
+                      <a:srgbClr val="333355"/>
+                    </a:solidFill>
+                  </a:tcPr>
+                </a:tc>
+              </a:tr>
+              <a:tr h="609600">
+                <a:tc>
+                  <a:txBody>
+                    <a:bodyPr/>
+                    <a:lstStyle/>
+                    <a:p>
+                      <a:pPr algn="ctr">
+                        <a:defRPr sz="1800">
+                          <a:solidFill>
+                            <a:srgbClr val="FFFFFF"/>
+                          </a:solidFill>
+                          <a:latin typeface="Calibri"/>
+                        </a:defRPr>
+                      </a:pPr>
+                      <a:r>
+                        <a:t>States</a:t>
+                      </a:r>
+                    </a:p>
+                  </a:txBody>
+                  <a:tcPr>
+                    <a:solidFill>
+                      <a:srgbClr val="22223A"/>
+                    </a:solidFill>
+                  </a:tcPr>
+                </a:tc>
+                <a:tc>
+                  <a:txBody>
+                    <a:bodyPr/>
+                    <a:lstStyle/>
+                    <a:p>
+                      <a:pPr algn="ctr">
+                        <a:defRPr sz="1800">
+                          <a:solidFill>
+                            <a:srgbClr val="CCCCCC"/>
+                          </a:solidFill>
+                          <a:latin typeface="Calibri"/>
+                        </a:defRPr>
+                      </a:pPr>
+                      <a:r>
+                        <a:t>41</a:t>
+                      </a:r>
+                    </a:p>
+                  </a:txBody>
+                  <a:tcPr>
+                    <a:solidFill>
+                      <a:srgbClr val="22223A"/>
+                    </a:solidFill>
+                  </a:tcPr>
+                </a:tc>
+                <a:tc>
+                  <a:txBody>
+                    <a:bodyPr/>
+                    <a:lstStyle/>
+                    <a:p>
+                      <a:pPr algn="ctr">
+                        <a:defRPr sz="1800" b="1">
+                          <a:solidFill>
+                            <a:srgbClr val="4EC98B"/>
+                          </a:solidFill>
+                          <a:latin typeface="Calibri"/>
+                        </a:defRPr>
+                      </a:pPr>
+                      <a:r>
+                        <a:t>441 (21x21)</a:t>
+                      </a:r>
+                    </a:p>
+                  </a:txBody>
+                  <a:tcPr>
+                    <a:solidFill>
+                      <a:srgbClr val="22223A"/>
+                    </a:solidFill>
+                  </a:tcPr>
+                </a:tc>
+              </a:tr>
+              <a:tr h="609600">
+                <a:tc>
+                  <a:txBody>
+                    <a:bodyPr/>
+                    <a:lstStyle/>
+                    <a:p>
+                      <a:pPr algn="ctr">
+                        <a:defRPr sz="1800">
+                          <a:solidFill>
+                            <a:srgbClr val="FFFFFF"/>
+                          </a:solidFill>
+                          <a:latin typeface="Calibri"/>
+                        </a:defRPr>
+                      </a:pPr>
+                      <a:r>
+                        <a:t>Actions</a:t>
+                      </a:r>
+                    </a:p>
+                  </a:txBody>
+                  <a:tcPr>
+                    <a:solidFill>
+                      <a:srgbClr val="282842"/>
+                    </a:solidFill>
+                  </a:tcPr>
+                </a:tc>
+                <a:tc>
+                  <a:txBody>
+                    <a:bodyPr/>
+                    <a:lstStyle/>
+                    <a:p>
+                      <a:pPr algn="ctr">
+                        <a:defRPr sz="1800">
+                          <a:solidFill>
+                            <a:srgbClr val="CCCCCC"/>
+                          </a:solidFill>
+                          <a:latin typeface="Calibri"/>
+                        </a:defRPr>
+                      </a:pPr>
+                      <a:r>
+                        <a:t>3</a:t>
+                      </a:r>
+                    </a:p>
+                  </a:txBody>
+                  <a:tcPr>
+                    <a:solidFill>
+                      <a:srgbClr val="282842"/>
+                    </a:solidFill>
+                  </a:tcPr>
+                </a:tc>
+                <a:tc>
+                  <a:txBody>
+                    <a:bodyPr/>
+                    <a:lstStyle/>
+                    <a:p>
+                      <a:pPr algn="ctr">
+                        <a:defRPr sz="1800" b="1">
+                          <a:solidFill>
+                            <a:srgbClr val="4EC98B"/>
+                          </a:solidFill>
+                          <a:latin typeface="Calibri"/>
+                        </a:defRPr>
+                      </a:pPr>
+                      <a:r>
+                        <a:t>9 (8 dirs + stay)</a:t>
+                      </a:r>
+                    </a:p>
+                  </a:txBody>
+                  <a:tcPr>
+                    <a:solidFill>
+                      <a:srgbClr val="282842"/>
+                    </a:solidFill>
+                  </a:tcPr>
+                </a:tc>
+              </a:tr>
+              <a:tr h="609600">
+                <a:tc>
+                  <a:txBody>
+                    <a:bodyPr/>
+                    <a:lstStyle/>
+                    <a:p>
+                      <a:pPr algn="ctr">
+                        <a:defRPr sz="1800">
+                          <a:solidFill>
+                            <a:srgbClr val="FFFFFF"/>
+                          </a:solidFill>
+                          <a:latin typeface="Calibri"/>
+                        </a:defRPr>
+                      </a:pPr>
+                      <a:r>
+                        <a:t>Q-table</a:t>
+                      </a:r>
+                    </a:p>
+                  </a:txBody>
+                  <a:tcPr>
+                    <a:solidFill>
+                      <a:srgbClr val="22223A"/>
+                    </a:solidFill>
+                  </a:tcPr>
+                </a:tc>
+                <a:tc>
+                  <a:txBody>
+                    <a:bodyPr/>
+                    <a:lstStyle/>
+                    <a:p>
+                      <a:pPr algn="ctr">
+                        <a:defRPr sz="1800">
+                          <a:solidFill>
+                            <a:srgbClr val="CCCCCC"/>
+                          </a:solidFill>
+                          <a:latin typeface="Calibri"/>
+                        </a:defRPr>
+                      </a:pPr>
+                      <a:r>
+                        <a:t>123 entries</a:t>
+                      </a:r>
+                    </a:p>
+                  </a:txBody>
+                  <a:tcPr>
+                    <a:solidFill>
+                      <a:srgbClr val="22223A"/>
+                    </a:solidFill>
+                  </a:tcPr>
+                </a:tc>
+                <a:tc>
+                  <a:txBody>
+                    <a:bodyPr/>
+                    <a:lstStyle/>
+                    <a:p>
+                      <a:pPr algn="ctr">
+                        <a:defRPr sz="1800" b="1">
+                          <a:solidFill>
+                            <a:srgbClr val="4EC98B"/>
+                          </a:solidFill>
+                          <a:latin typeface="Calibri"/>
+                        </a:defRPr>
+                      </a:pPr>
+                      <a:r>
+                        <a:t>3,969 entries</a:t>
+                      </a:r>
+                    </a:p>
+                  </a:txBody>
+                  <a:tcPr>
+                    <a:solidFill>
+                      <a:srgbClr val="22223A"/>
+                    </a:solidFill>
+                  </a:tcPr>
+                </a:tc>
+              </a:tr>
+              <a:tr h="609600">
+                <a:tc>
+                  <a:txBody>
+                    <a:bodyPr/>
+                    <a:lstStyle/>
+                    <a:p>
+                      <a:pPr algn="ctr">
+                        <a:defRPr sz="1800">
+                          <a:solidFill>
+                            <a:srgbClr val="FFFFFF"/>
+                          </a:solidFill>
+                          <a:latin typeface="Calibri"/>
+                        </a:defRPr>
+                      </a:pPr>
+                      <a:r>
+                        <a:t>Target</a:t>
+                      </a:r>
+                    </a:p>
+                  </a:txBody>
+                  <a:tcPr>
+                    <a:solidFill>
+                      <a:srgbClr val="282842"/>
+                    </a:solidFill>
+                  </a:tcPr>
+                </a:tc>
+                <a:tc>
+                  <a:txBody>
+                    <a:bodyPr/>
+                    <a:lstStyle/>
+                    <a:p>
+                      <a:pPr algn="ctr">
+                        <a:defRPr sz="1800">
+                          <a:solidFill>
+                            <a:srgbClr val="CCCCCC"/>
+                          </a:solidFill>
+                          <a:latin typeface="Calibri"/>
+                        </a:defRPr>
+                      </a:pPr>
+                      <a:r>
+                        <a:t>Sine wave</a:t>
+                      </a:r>
+                    </a:p>
+                  </a:txBody>
+                  <a:tcPr>
+                    <a:solidFill>
+                      <a:srgbClr val="282842"/>
+                    </a:solidFill>
+                  </a:tcPr>
+                </a:tc>
+                <a:tc>
+                  <a:txBody>
+                    <a:bodyPr/>
+                    <a:lstStyle/>
+                    <a:p>
+                      <a:pPr algn="ctr">
+                        <a:defRPr sz="1800" b="1">
+                          <a:solidFill>
+                            <a:srgbClr val="4EC98B"/>
+                          </a:solidFill>
+                          <a:latin typeface="Calibri"/>
+                        </a:defRPr>
+                      </a:pPr>
+                      <a:r>
+                        <a:t>Figure-eight</a:t>
+                      </a:r>
+                    </a:p>
+                  </a:txBody>
+                  <a:tcPr>
+                    <a:solidFill>
+                      <a:srgbClr val="282842"/>
+                    </a:solidFill>
+                  </a:tcPr>
+                </a:tc>
+              </a:tr>
+              <a:tr h="609600">
+                <a:tc>
+                  <a:txBody>
+                    <a:bodyPr/>
+                    <a:lstStyle/>
+                    <a:p>
+                      <a:pPr algn="ctr">
+                        <a:defRPr sz="1800">
+                          <a:solidFill>
+                            <a:srgbClr val="FFFFFF"/>
+                          </a:solidFill>
+                          <a:latin typeface="Calibri"/>
+                        </a:defRPr>
+                      </a:pPr>
+                      <a:r>
+                        <a:t>Training</a:t>
+                      </a:r>
+                    </a:p>
+                  </a:txBody>
+                  <a:tcPr>
+                    <a:solidFill>
+                      <a:srgbClr val="22223A"/>
+                    </a:solidFill>
+                  </a:tcPr>
+                </a:tc>
+                <a:tc>
+                  <a:txBody>
+                    <a:bodyPr/>
+                    <a:lstStyle/>
+                    <a:p>
+                      <a:pPr algn="ctr">
+                        <a:defRPr sz="1800">
+                          <a:solidFill>
+                            <a:srgbClr val="CCCCCC"/>
+                          </a:solidFill>
+                          <a:latin typeface="Calibri"/>
+                        </a:defRPr>
+                      </a:pPr>
+                      <a:r>
+                        <a:t>500 episodes</a:t>
+                      </a:r>
+                    </a:p>
+                  </a:txBody>
+                  <a:tcPr>
+                    <a:solidFill>
+                      <a:srgbClr val="22223A"/>
+                    </a:solidFill>
+                  </a:tcPr>
+                </a:tc>
+                <a:tc>
+                  <a:txBody>
+                    <a:bodyPr/>
+                    <a:lstStyle/>
+                    <a:p>
+                      <a:pPr algn="ctr">
+                        <a:defRPr sz="1800" b="1">
+                          <a:solidFill>
+                            <a:srgbClr val="4EC98B"/>
+                          </a:solidFill>
+                          <a:latin typeface="Calibri"/>
+                        </a:defRPr>
+                      </a:pPr>
+                      <a:r>
+                        <a:t>800 episodes</a:t>
+                      </a:r>
+                    </a:p>
+                  </a:txBody>
+                  <a:tcPr>
+                    <a:solidFill>
+                      <a:srgbClr val="22223A"/>
+                    </a:solidFill>
+                  </a:tcPr>
+                </a:tc>
+              </a:tr>
+            </a:tbl>
+          </a:graphicData>
+        </a:graphic>
+      </p:graphicFrame>
+      <p:sp>
+        <p:nvSpPr>
+          <p:cNvPr id="6" name="Rounded Rectangle 5"/>
+          <p:cNvSpPr/>
+          <p:nvPr/>
+        </p:nvSpPr>
+        <p:spPr>
+          <a:xfrm>
+            <a:off x="6217920" y="1371600"/>
+            <a:ext cx="5303520" cy="4754880"/>
+          </a:xfrm>
+          <a:prstGeom prst="roundRect">
+            <a:avLst/>
+          </a:prstGeom>
+          <a:solidFill>
+            <a:srgbClr val="333355"/>
+          </a:solidFill>
+          <a:ln>
+            <a:noFill/>
+          </a:ln>
+        </p:spPr>
+        <p:style>
+          <a:lnRef idx="1">
+            <a:schemeClr val="accent1"/>
+          </a:lnRef>
+          <a:fillRef idx="3">
+            <a:schemeClr val="accent1"/>
+          </a:fillRef>
+          <a:effectRef idx="2">
+            <a:schemeClr val="accent1"/>
+          </a:effectRef>
+          <a:fontRef idx="minor">
+            <a:schemeClr val="lt1"/>
+          </a:fontRef>
+        </p:style>
+        <p:txBody>
+          <a:bodyPr rtlCol="0" anchor="ctr"/>
+          <a:lstStyle/>
+          <a:p>
+            <a:pPr algn="ctr"/>
+          </a:p>
+        </p:txBody>
+      </p:sp>
+      <p:sp>
+        <p:nvSpPr>
+          <p:cNvPr id="7" name="TextBox 6"/>
           <p:cNvSpPr txBox="1"/>
           <p:nvPr/>
         </p:nvSpPr>
         <p:spPr>
           <a:xfrm>
-            <a:off x="914400" y="4572000"/>
-            <a:ext cx="10058400" cy="1371600"/>
+            <a:off x="6400800" y="1554480"/>
+            <a:ext cx="4937760" cy="4572000"/>
           </a:xfrm>
           <a:prstGeom prst="rect">
             <a:avLst/>
@@ -7603,11 +7855,11 @@
           </a:bodyPr>
           <a:lstStyle/>
           <a:p>
-            <a:pPr algn="ctr">
-              <a:lnSpc>
-                <a:spcPts val="5600"/>
-              </a:lnSpc>
-              <a:defRPr sz="4000" b="1">
+            <a:pPr algn="l">
+              <a:lnSpc>
+                <a:spcPts val="2600"/>
+              </a:lnSpc>
+              <a:defRPr sz="2200" b="1">
                 <a:solidFill>
                   <a:srgbClr val="F5C542"/>
                 </a:solidFill>
@@ -7615,15 +7867,181 @@
               </a:defRPr>
             </a:pPr>
             <a:r>
-              <a:t>Put down the scalpel.</a:t>
+              <a:t>Why 2D changes everything</a:t>
+            </a:r>
+          </a:p>
+          <a:p>
+            <a:pPr algn="l">
+              <a:lnSpc>
+                <a:spcPts val="900"/>
+              </a:lnSpc>
+              <a:spcBef>
+                <a:spcPts val="0"/>
+              </a:spcBef>
+              <a:defRPr sz="800" b="0">
+                <a:solidFill>
+                  <a:srgbClr val="FFFFFF"/>
+                </a:solidFill>
+                <a:latin typeface="Calibri"/>
+              </a:defRPr>
+            </a:pPr>
+          </a:p>
+          <a:p>
+            <a:pPr algn="l">
+              <a:lnSpc>
+                <a:spcPts val="2400"/>
+              </a:lnSpc>
+              <a:spcBef>
+                <a:spcPts val="1400"/>
+              </a:spcBef>
+              <a:defRPr sz="2000" b="1">
+                <a:solidFill>
+                  <a:srgbClr val="4EC98B"/>
+                </a:solidFill>
+                <a:latin typeface="Calibri"/>
+              </a:defRPr>
+            </a:pPr>
+            <a:r>
+              <a:t>32x larger Q-table</a:t>
+            </a:r>
+          </a:p>
+          <a:p>
+            <a:pPr algn="l">
+              <a:lnSpc>
+                <a:spcPts val="1900"/>
+              </a:lnSpc>
+              <a:spcBef>
+                <a:spcPts val="400"/>
+              </a:spcBef>
+              <a:defRPr sz="1600" b="0">
+                <a:solidFill>
+                  <a:srgbClr val="CCCCCC"/>
+                </a:solidFill>
+                <a:latin typeface="Calibri"/>
+              </a:defRPr>
+            </a:pPr>
+            <a:r>
+              <a:t>Many states visited rarely — corrupted</a:t>
             </a:r>
             <a:br/>
             <a:r>
-              <a:t>Wait for a clear picture.</a:t>
+              <a:t>updates can flip the best action</a:t>
+            </a:r>
+          </a:p>
+          <a:p>
+            <a:pPr algn="l">
+              <a:lnSpc>
+                <a:spcPts val="700"/>
+              </a:lnSpc>
+              <a:spcBef>
+                <a:spcPts val="0"/>
+              </a:spcBef>
+              <a:defRPr sz="600" b="0">
+                <a:solidFill>
+                  <a:srgbClr val="FFFFFF"/>
+                </a:solidFill>
+                <a:latin typeface="Calibri"/>
+              </a:defRPr>
+            </a:pPr>
+          </a:p>
+          <a:p>
+            <a:pPr algn="l">
+              <a:lnSpc>
+                <a:spcPts val="2400"/>
+              </a:lnSpc>
+              <a:spcBef>
+                <a:spcPts val="1400"/>
+              </a:spcBef>
+              <a:defRPr sz="2000" b="1">
+                <a:solidFill>
+                  <a:srgbClr val="4EC98B"/>
+                </a:solidFill>
+                <a:latin typeface="Calibri"/>
+              </a:defRPr>
+            </a:pPr>
+            <a:r>
+              <a:t>3x more actions</a:t>
+            </a:r>
+          </a:p>
+          <a:p>
+            <a:pPr algn="l">
+              <a:lnSpc>
+                <a:spcPts val="1900"/>
+              </a:lnSpc>
+              <a:spcBef>
+                <a:spcPts val="400"/>
+              </a:spcBef>
+              <a:defRPr sz="1600" b="0">
+                <a:solidFill>
+                  <a:srgbClr val="CCCCCC"/>
+                </a:solidFill>
+                <a:latin typeface="Calibri"/>
+              </a:defRPr>
+            </a:pPr>
+            <a:r>
+              <a:t>Choosing between 8 directions is</a:t>
             </a:r>
             <a:br/>
             <a:r>
-              <a:t>Then cut.</a:t>
+              <a:t>ambiguous — noise promotes wrong ones</a:t>
+            </a:r>
+          </a:p>
+          <a:p>
+            <a:pPr algn="l">
+              <a:lnSpc>
+                <a:spcPts val="700"/>
+              </a:lnSpc>
+              <a:spcBef>
+                <a:spcPts val="0"/>
+              </a:spcBef>
+              <a:defRPr sz="600" b="0">
+                <a:solidFill>
+                  <a:srgbClr val="FFFFFF"/>
+                </a:solidFill>
+                <a:latin typeface="Calibri"/>
+              </a:defRPr>
+            </a:pPr>
+          </a:p>
+          <a:p>
+            <a:pPr algn="l">
+              <a:lnSpc>
+                <a:spcPts val="2400"/>
+              </a:lnSpc>
+              <a:spcBef>
+                <a:spcPts val="1400"/>
+              </a:spcBef>
+              <a:defRPr sz="2000" b="1">
+                <a:solidFill>
+                  <a:srgbClr val="4EC98B"/>
+                </a:solidFill>
+                <a:latin typeface="Calibri"/>
+              </a:defRPr>
+            </a:pPr>
+            <a:r>
+              <a:t>2D stale states</a:t>
+            </a:r>
+          </a:p>
+          <a:p>
+            <a:pPr algn="l">
+              <a:lnSpc>
+                <a:spcPts val="1900"/>
+              </a:lnSpc>
+              <a:spcBef>
+                <a:spcPts val="400"/>
+              </a:spcBef>
+              <a:defRPr sz="1600" b="0">
+                <a:solidFill>
+                  <a:srgbClr val="CCCCCC"/>
+                </a:solidFill>
+                <a:latin typeface="Calibri"/>
+              </a:defRPr>
+            </a:pPr>
+            <a:r>
+              <a:t>Wrong in both X and Y simultaneously</a:t>
+            </a:r>
+            <a:br/>
+            <a:r>
+              <a:t>— bigger mistakes, harder to recover</a:t>
             </a:r>
           </a:p>
         </p:txBody>
@@ -7798,6 +8216,2160 @@
 </file>
 
 <file path=ppt/slides/slide20.xml><?xml version="1.0" encoding="utf-8"?>
+<p:sld xmlns:a="http://schemas.openxmlformats.org/drawingml/2006/main" xmlns:p="http://schemas.openxmlformats.org/presentationml/2006/main" xmlns:r="http://schemas.openxmlformats.org/officeDocument/2006/relationships">
+  <p:cSld>
+    <p:bg>
+      <p:bgPr>
+        <a:solidFill>
+          <a:srgbClr val="1A1A2E"/>
+        </a:solidFill>
+        <a:effectLst/>
+      </p:bgPr>
+    </p:bg>
+    <p:spTree>
+      <p:nvGrpSpPr>
+        <p:cNvPr id="1" name=""/>
+        <p:cNvGrpSpPr/>
+        <p:nvPr/>
+      </p:nvGrpSpPr>
+      <p:grpSpPr/>
+      <p:sp>
+        <p:nvSpPr>
+          <p:cNvPr id="2" name="TextBox 1"/>
+          <p:cNvSpPr txBox="1"/>
+          <p:nvPr/>
+        </p:nvSpPr>
+        <p:spPr>
+          <a:xfrm>
+            <a:off x="731520" y="182880"/>
+            <a:ext cx="10058400" cy="640080"/>
+          </a:xfrm>
+          <a:prstGeom prst="rect">
+            <a:avLst/>
+          </a:prstGeom>
+          <a:noFill/>
+        </p:spPr>
+        <p:txBody>
+          <a:bodyPr wrap="square">
+            <a:spAutoFit/>
+          </a:bodyPr>
+          <a:lstStyle/>
+          <a:p>
+            <a:pPr algn="l">
+              <a:lnSpc>
+                <a:spcPts val="4500"/>
+              </a:lnSpc>
+              <a:defRPr sz="3800" b="1">
+                <a:solidFill>
+                  <a:srgbClr val="FFFFFF"/>
+                </a:solidFill>
+                <a:latin typeface="Calibri"/>
+              </a:defRPr>
+            </a:pPr>
+            <a:r>
+              <a:t>2D Trajectories: The Difference Is Visible</a:t>
+            </a:r>
+          </a:p>
+        </p:txBody>
+      </p:sp>
+      <p:pic>
+        <p:nvPicPr>
+          <p:cNvPr id="3" name="Picture 2" descr="2_trajectories_2d.png"/>
+          <p:cNvPicPr>
+            <a:picLocks noChangeAspect="1"/>
+          </p:cNvPicPr>
+          <p:nvPr/>
+        </p:nvPicPr>
+        <p:blipFill>
+          <a:blip r:embed="rId2"/>
+          <a:stretch>
+            <a:fillRect/>
+          </a:stretch>
+        </p:blipFill>
+        <p:spPr>
+          <a:xfrm>
+            <a:off x="457200" y="1005840"/>
+            <a:ext cx="11247120" cy="3749040"/>
+          </a:xfrm>
+          <a:prstGeom prst="rect">
+            <a:avLst/>
+          </a:prstGeom>
+        </p:spPr>
+      </p:pic>
+      <p:sp>
+        <p:nvSpPr>
+          <p:cNvPr id="4" name="TextBox 3"/>
+          <p:cNvSpPr txBox="1"/>
+          <p:nvPr/>
+        </p:nvSpPr>
+        <p:spPr>
+          <a:xfrm>
+            <a:off x="731520" y="5669280"/>
+            <a:ext cx="10515600" cy="914400"/>
+          </a:xfrm>
+          <a:prstGeom prst="rect">
+            <a:avLst/>
+          </a:prstGeom>
+          <a:noFill/>
+        </p:spPr>
+        <p:txBody>
+          <a:bodyPr wrap="square">
+            <a:spAutoFit/>
+          </a:bodyPr>
+          <a:lstStyle/>
+          <a:p>
+            <a:pPr algn="ctr">
+              <a:lnSpc>
+                <a:spcPts val="2100"/>
+              </a:lnSpc>
+              <a:defRPr sz="1800" b="0">
+                <a:solidFill>
+                  <a:srgbClr val="CCCCCC"/>
+                </a:solidFill>
+                <a:latin typeface="Calibri"/>
+              </a:defRPr>
+            </a:pPr>
+            <a:r>
+              <a:t>Dropout-Aware (blue) traces the figure-eight more smoothly. Naive (red) shows sharper deviations from corrupted Q-table entries.</a:t>
+            </a:r>
+          </a:p>
+        </p:txBody>
+      </p:sp>
+    </p:spTree>
+  </p:cSld>
+  <p:clrMapOvr>
+    <a:masterClrMapping/>
+  </p:clrMapOvr>
+</p:sld>
+</file>
+
+<file path=ppt/slides/slide21.xml><?xml version="1.0" encoding="utf-8"?>
+<p:sld xmlns:a="http://schemas.openxmlformats.org/drawingml/2006/main" xmlns:p="http://schemas.openxmlformats.org/presentationml/2006/main" xmlns:r="http://schemas.openxmlformats.org/officeDocument/2006/relationships">
+  <p:cSld>
+    <p:bg>
+      <p:bgPr>
+        <a:solidFill>
+          <a:srgbClr val="1A1A2E"/>
+        </a:solidFill>
+        <a:effectLst/>
+      </p:bgPr>
+    </p:bg>
+    <p:spTree>
+      <p:nvGrpSpPr>
+        <p:cNvPr id="1" name=""/>
+        <p:cNvGrpSpPr/>
+        <p:nvPr/>
+      </p:nvGrpSpPr>
+      <p:grpSpPr/>
+      <p:sp>
+        <p:nvSpPr>
+          <p:cNvPr id="2" name="TextBox 1"/>
+          <p:cNvSpPr txBox="1"/>
+          <p:nvPr/>
+        </p:nvSpPr>
+        <p:spPr>
+          <a:xfrm>
+            <a:off x="731520" y="274320"/>
+            <a:ext cx="5486400" cy="731520"/>
+          </a:xfrm>
+          <a:prstGeom prst="rect">
+            <a:avLst/>
+          </a:prstGeom>
+          <a:noFill/>
+        </p:spPr>
+        <p:txBody>
+          <a:bodyPr wrap="square">
+            <a:spAutoFit/>
+          </a:bodyPr>
+          <a:lstStyle/>
+          <a:p>
+            <a:pPr algn="l">
+              <a:lnSpc>
+                <a:spcPts val="4800"/>
+              </a:lnSpc>
+              <a:defRPr sz="4000" b="1">
+                <a:solidFill>
+                  <a:srgbClr val="FFFFFF"/>
+                </a:solidFill>
+                <a:latin typeface="Calibri"/>
+              </a:defRPr>
+            </a:pPr>
+            <a:r>
+              <a:t>2D Results: The Gap Is Real</a:t>
+            </a:r>
+          </a:p>
+        </p:txBody>
+      </p:sp>
+      <p:graphicFrame>
+        <p:nvGraphicFramePr>
+          <p:cNvPr id="3" name="Table 2"/>
+          <p:cNvGraphicFramePr>
+            <a:graphicFrameLocks noGrp="1"/>
+          </p:cNvGraphicFramePr>
+          <p:nvPr/>
+        </p:nvGraphicFramePr>
+        <p:xfrm>
+          <a:off x="731520" y="1371600"/>
+          <a:ext cx="6400800" cy="2743200"/>
+        </p:xfrm>
+        <a:graphic>
+          <a:graphicData uri="http://schemas.openxmlformats.org/drawingml/2006/table">
+            <a:tbl>
+              <a:tblPr firstRow="1" bandRow="1">
+                <a:tableStyleId>{5C22544A-7EE6-4342-B048-85BDC9FD1C3A}</a:tableStyleId>
+              </a:tblPr>
+              <a:tblGrid>
+                <a:gridCol w="2286000"/>
+                <a:gridCol w="2057400"/>
+                <a:gridCol w="2057400"/>
+              </a:tblGrid>
+              <a:tr h="685800">
+                <a:tc>
+                  <a:txBody>
+                    <a:bodyPr/>
+                    <a:lstStyle/>
+                    <a:p>
+                      <a:pPr algn="ctr">
+                        <a:defRPr sz="2200" b="1">
+                          <a:solidFill>
+                            <a:srgbClr val="F5C542"/>
+                          </a:solidFill>
+                          <a:latin typeface="Calibri"/>
+                        </a:defRPr>
+                      </a:pPr>
+                      <a:r>
+                        <a:t>Agent</a:t>
+                      </a:r>
+                    </a:p>
+                  </a:txBody>
+                  <a:tcPr>
+                    <a:solidFill>
+                      <a:srgbClr val="333355"/>
+                    </a:solidFill>
+                  </a:tcPr>
+                </a:tc>
+                <a:tc>
+                  <a:txBody>
+                    <a:bodyPr/>
+                    <a:lstStyle/>
+                    <a:p>
+                      <a:pPr algn="ctr">
+                        <a:defRPr sz="2200" b="1">
+                          <a:solidFill>
+                            <a:srgbClr val="F5C542"/>
+                          </a:solidFill>
+                          <a:latin typeface="Calibri"/>
+                        </a:defRPr>
+                      </a:pPr>
+                      <a:r>
+                        <a:t>Mean Track Error</a:t>
+                      </a:r>
+                    </a:p>
+                  </a:txBody>
+                  <a:tcPr>
+                    <a:solidFill>
+                      <a:srgbClr val="333355"/>
+                    </a:solidFill>
+                  </a:tcPr>
+                </a:tc>
+                <a:tc>
+                  <a:txBody>
+                    <a:bodyPr/>
+                    <a:lstStyle/>
+                    <a:p>
+                      <a:pPr algn="ctr">
+                        <a:defRPr sz="2200" b="1">
+                          <a:solidFill>
+                            <a:srgbClr val="F5C542"/>
+                          </a:solidFill>
+                          <a:latin typeface="Calibri"/>
+                        </a:defRPr>
+                      </a:pPr>
+                      <a:r>
+                        <a:t>Total Reward</a:t>
+                      </a:r>
+                    </a:p>
+                  </a:txBody>
+                  <a:tcPr>
+                    <a:solidFill>
+                      <a:srgbClr val="333355"/>
+                    </a:solidFill>
+                  </a:tcPr>
+                </a:tc>
+              </a:tr>
+              <a:tr h="685800">
+                <a:tc>
+                  <a:txBody>
+                    <a:bodyPr/>
+                    <a:lstStyle/>
+                    <a:p>
+                      <a:pPr algn="ctr">
+                        <a:defRPr sz="2200">
+                          <a:solidFill>
+                            <a:srgbClr val="F08C3A"/>
+                          </a:solidFill>
+                          <a:latin typeface="Calibri"/>
+                        </a:defRPr>
+                      </a:pPr>
+                      <a:r>
+                        <a:t>Baseline (no drop)</a:t>
+                      </a:r>
+                    </a:p>
+                  </a:txBody>
+                  <a:tcPr>
+                    <a:solidFill>
+                      <a:srgbClr val="22223A"/>
+                    </a:solidFill>
+                  </a:tcPr>
+                </a:tc>
+                <a:tc>
+                  <a:txBody>
+                    <a:bodyPr/>
+                    <a:lstStyle/>
+                    <a:p>
+                      <a:pPr algn="ctr">
+                        <a:defRPr sz="2200">
+                          <a:solidFill>
+                            <a:srgbClr val="F08C3A"/>
+                          </a:solidFill>
+                          <a:latin typeface="Calibri"/>
+                        </a:defRPr>
+                      </a:pPr>
+                      <a:r>
+                        <a:t>0.2373</a:t>
+                      </a:r>
+                    </a:p>
+                  </a:txBody>
+                  <a:tcPr>
+                    <a:solidFill>
+                      <a:srgbClr val="22223A"/>
+                    </a:solidFill>
+                  </a:tcPr>
+                </a:tc>
+                <a:tc>
+                  <a:txBody>
+                    <a:bodyPr/>
+                    <a:lstStyle/>
+                    <a:p>
+                      <a:pPr algn="ctr">
+                        <a:defRPr sz="2200">
+                          <a:solidFill>
+                            <a:srgbClr val="F08C3A"/>
+                          </a:solidFill>
+                          <a:latin typeface="Calibri"/>
+                        </a:defRPr>
+                      </a:pPr>
+                      <a:r>
+                        <a:t>-85.44</a:t>
+                      </a:r>
+                    </a:p>
+                  </a:txBody>
+                  <a:tcPr>
+                    <a:solidFill>
+                      <a:srgbClr val="22223A"/>
+                    </a:solidFill>
+                  </a:tcPr>
+                </a:tc>
+              </a:tr>
+              <a:tr h="685800">
+                <a:tc>
+                  <a:txBody>
+                    <a:bodyPr/>
+                    <a:lstStyle/>
+                    <a:p>
+                      <a:pPr algn="ctr">
+                        <a:defRPr sz="2200">
+                          <a:solidFill>
+                            <a:srgbClr val="FFFFFF"/>
+                          </a:solidFill>
+                          <a:latin typeface="Calibri"/>
+                        </a:defRPr>
+                      </a:pPr>
+                      <a:r>
+                        <a:t>Naive (30% drop)</a:t>
+                      </a:r>
+                    </a:p>
+                  </a:txBody>
+                  <a:tcPr>
+                    <a:solidFill>
+                      <a:srgbClr val="282842"/>
+                    </a:solidFill>
+                  </a:tcPr>
+                </a:tc>
+                <a:tc>
+                  <a:txBody>
+                    <a:bodyPr/>
+                    <a:lstStyle/>
+                    <a:p>
+                      <a:pPr algn="ctr">
+                        <a:defRPr sz="2200">
+                          <a:solidFill>
+                            <a:srgbClr val="FFFFFF"/>
+                          </a:solidFill>
+                          <a:latin typeface="Calibri"/>
+                        </a:defRPr>
+                      </a:pPr>
+                      <a:r>
+                        <a:t>0.4413</a:t>
+                      </a:r>
+                    </a:p>
+                  </a:txBody>
+                  <a:tcPr>
+                    <a:solidFill>
+                      <a:srgbClr val="282842"/>
+                    </a:solidFill>
+                  </a:tcPr>
+                </a:tc>
+                <a:tc>
+                  <a:txBody>
+                    <a:bodyPr/>
+                    <a:lstStyle/>
+                    <a:p>
+                      <a:pPr algn="ctr">
+                        <a:defRPr sz="2200">
+                          <a:solidFill>
+                            <a:srgbClr val="FFFFFF"/>
+                          </a:solidFill>
+                          <a:latin typeface="Calibri"/>
+                        </a:defRPr>
+                      </a:pPr>
+                      <a:r>
+                        <a:t>-158.87</a:t>
+                      </a:r>
+                    </a:p>
+                  </a:txBody>
+                  <a:tcPr>
+                    <a:solidFill>
+                      <a:srgbClr val="282842"/>
+                    </a:solidFill>
+                  </a:tcPr>
+                </a:tc>
+              </a:tr>
+              <a:tr h="685800">
+                <a:tc>
+                  <a:txBody>
+                    <a:bodyPr/>
+                    <a:lstStyle/>
+                    <a:p>
+                      <a:pPr algn="ctr">
+                        <a:defRPr sz="2200" b="1">
+                          <a:solidFill>
+                            <a:srgbClr val="4EC98B"/>
+                          </a:solidFill>
+                          <a:latin typeface="Calibri"/>
+                        </a:defRPr>
+                      </a:pPr>
+                      <a:r>
+                        <a:t>Dropout-Aware (30%)</a:t>
+                      </a:r>
+                    </a:p>
+                  </a:txBody>
+                  <a:tcPr>
+                    <a:solidFill>
+                      <a:srgbClr val="22223A"/>
+                    </a:solidFill>
+                  </a:tcPr>
+                </a:tc>
+                <a:tc>
+                  <a:txBody>
+                    <a:bodyPr/>
+                    <a:lstStyle/>
+                    <a:p>
+                      <a:pPr algn="ctr">
+                        <a:defRPr sz="2200" b="1">
+                          <a:solidFill>
+                            <a:srgbClr val="4EC98B"/>
+                          </a:solidFill>
+                          <a:latin typeface="Calibri"/>
+                        </a:defRPr>
+                      </a:pPr>
+                      <a:r>
+                        <a:t>0.3730</a:t>
+                      </a:r>
+                    </a:p>
+                  </a:txBody>
+                  <a:tcPr>
+                    <a:solidFill>
+                      <a:srgbClr val="22223A"/>
+                    </a:solidFill>
+                  </a:tcPr>
+                </a:tc>
+                <a:tc>
+                  <a:txBody>
+                    <a:bodyPr/>
+                    <a:lstStyle/>
+                    <a:p>
+                      <a:pPr algn="ctr">
+                        <a:defRPr sz="2200" b="1">
+                          <a:solidFill>
+                            <a:srgbClr val="4EC98B"/>
+                          </a:solidFill>
+                          <a:latin typeface="Calibri"/>
+                        </a:defRPr>
+                      </a:pPr>
+                      <a:r>
+                        <a:t>-134.29</a:t>
+                      </a:r>
+                    </a:p>
+                  </a:txBody>
+                  <a:tcPr>
+                    <a:solidFill>
+                      <a:srgbClr val="22223A"/>
+                    </a:solidFill>
+                  </a:tcPr>
+                </a:tc>
+              </a:tr>
+            </a:tbl>
+          </a:graphicData>
+        </a:graphic>
+      </p:graphicFrame>
+      <p:sp>
+        <p:nvSpPr>
+          <p:cNvPr id="4" name="Rounded Rectangle 3"/>
+          <p:cNvSpPr/>
+          <p:nvPr/>
+        </p:nvSpPr>
+        <p:spPr>
+          <a:xfrm>
+            <a:off x="731520" y="4389120"/>
+            <a:ext cx="6400800" cy="1645920"/>
+          </a:xfrm>
+          <a:prstGeom prst="roundRect">
+            <a:avLst/>
+          </a:prstGeom>
+          <a:solidFill>
+            <a:srgbClr val="1E3A5C"/>
+          </a:solidFill>
+          <a:ln>
+            <a:noFill/>
+          </a:ln>
+        </p:spPr>
+        <p:style>
+          <a:lnRef idx="1">
+            <a:schemeClr val="accent1"/>
+          </a:lnRef>
+          <a:fillRef idx="3">
+            <a:schemeClr val="accent1"/>
+          </a:fillRef>
+          <a:effectRef idx="2">
+            <a:schemeClr val="accent1"/>
+          </a:effectRef>
+          <a:fontRef idx="minor">
+            <a:schemeClr val="lt1"/>
+          </a:fontRef>
+        </p:style>
+        <p:txBody>
+          <a:bodyPr rtlCol="0" anchor="ctr"/>
+          <a:lstStyle/>
+          <a:p>
+            <a:pPr algn="ctr"/>
+          </a:p>
+        </p:txBody>
+      </p:sp>
+      <p:sp>
+        <p:nvSpPr>
+          <p:cNvPr id="5" name="TextBox 4"/>
+          <p:cNvSpPr txBox="1"/>
+          <p:nvPr/>
+        </p:nvSpPr>
+        <p:spPr>
+          <a:xfrm>
+            <a:off x="914400" y="4480560"/>
+            <a:ext cx="6035040" cy="1463040"/>
+          </a:xfrm>
+          <a:prstGeom prst="rect">
+            <a:avLst/>
+          </a:prstGeom>
+          <a:noFill/>
+        </p:spPr>
+        <p:txBody>
+          <a:bodyPr wrap="square">
+            <a:spAutoFit/>
+          </a:bodyPr>
+          <a:lstStyle/>
+          <a:p>
+            <a:pPr algn="l">
+              <a:lnSpc>
+                <a:spcPts val="3100"/>
+              </a:lnSpc>
+              <a:defRPr sz="2600" b="1">
+                <a:solidFill>
+                  <a:srgbClr val="4EC98B"/>
+                </a:solidFill>
+                <a:latin typeface="Calibri"/>
+              </a:defRPr>
+            </a:pPr>
+            <a:r>
+              <a:t>Dropout-Aware beats Naive by 15.5%</a:t>
+            </a:r>
+          </a:p>
+          <a:p>
+            <a:pPr algn="l">
+              <a:lnSpc>
+                <a:spcPts val="700"/>
+              </a:lnSpc>
+              <a:spcBef>
+                <a:spcPts val="0"/>
+              </a:spcBef>
+              <a:defRPr sz="600" b="0">
+                <a:solidFill>
+                  <a:srgbClr val="FFFFFF"/>
+                </a:solidFill>
+                <a:latin typeface="Calibri"/>
+              </a:defRPr>
+            </a:pPr>
+          </a:p>
+          <a:p>
+            <a:pPr algn="l">
+              <a:lnSpc>
+                <a:spcPts val="2400"/>
+              </a:lnSpc>
+              <a:spcBef>
+                <a:spcPts val="800"/>
+              </a:spcBef>
+              <a:defRPr sz="2000" b="0">
+                <a:solidFill>
+                  <a:srgbClr val="FFFFFF"/>
+                </a:solidFill>
+                <a:latin typeface="Calibri"/>
+              </a:defRPr>
+            </a:pPr>
+            <a:r>
+              <a:t>Unlike 1D, the policies are now DIFFERENT.</a:t>
+            </a:r>
+          </a:p>
+          <a:p>
+            <a:pPr algn="l">
+              <a:lnSpc>
+                <a:spcPts val="2100"/>
+              </a:lnSpc>
+              <a:spcBef>
+                <a:spcPts val="600"/>
+              </a:spcBef>
+              <a:defRPr sz="1800" b="0">
+                <a:solidFill>
+                  <a:srgbClr val="CCCCCC"/>
+                </a:solidFill>
+                <a:latin typeface="Calibri"/>
+              </a:defRPr>
+            </a:pPr>
+            <a:r>
+              <a:t>Corrupted Q-table entries produce wrong actions</a:t>
+            </a:r>
+            <a:br/>
+            <a:r>
+              <a:t>in rarely-visited states.</a:t>
+            </a:r>
+          </a:p>
+        </p:txBody>
+      </p:sp>
+      <p:pic>
+        <p:nvPicPr>
+          <p:cNvPr id="6" name="Picture 5" descr="4_eval_comparison.png"/>
+          <p:cNvPicPr>
+            <a:picLocks noChangeAspect="1"/>
+          </p:cNvPicPr>
+          <p:nvPr/>
+        </p:nvPicPr>
+        <p:blipFill>
+          <a:blip r:embed="rId2"/>
+          <a:stretch>
+            <a:fillRect/>
+          </a:stretch>
+        </p:blipFill>
+        <p:spPr>
+          <a:xfrm>
+            <a:off x="7315200" y="1188720"/>
+            <a:ext cx="4572000" cy="1905000"/>
+          </a:xfrm>
+          <a:prstGeom prst="rect">
+            <a:avLst/>
+          </a:prstGeom>
+        </p:spPr>
+      </p:pic>
+    </p:spTree>
+  </p:cSld>
+  <p:clrMapOvr>
+    <a:masterClrMapping/>
+  </p:clrMapOvr>
+</p:sld>
+</file>
+
+<file path=ppt/slides/slide22.xml><?xml version="1.0" encoding="utf-8"?>
+<p:sld xmlns:a="http://schemas.openxmlformats.org/drawingml/2006/main" xmlns:p="http://schemas.openxmlformats.org/presentationml/2006/main" xmlns:r="http://schemas.openxmlformats.org/officeDocument/2006/relationships">
+  <p:cSld>
+    <p:bg>
+      <p:bgPr>
+        <a:solidFill>
+          <a:srgbClr val="1A1A2E"/>
+        </a:solidFill>
+        <a:effectLst/>
+      </p:bgPr>
+    </p:bg>
+    <p:spTree>
+      <p:nvGrpSpPr>
+        <p:cNvPr id="1" name=""/>
+        <p:cNvGrpSpPr/>
+        <p:nvPr/>
+      </p:nvGrpSpPr>
+      <p:grpSpPr/>
+      <p:sp>
+        <p:nvSpPr>
+          <p:cNvPr id="2" name="TextBox 1"/>
+          <p:cNvSpPr txBox="1"/>
+          <p:nvPr/>
+        </p:nvSpPr>
+        <p:spPr>
+          <a:xfrm>
+            <a:off x="731520" y="274320"/>
+            <a:ext cx="10515600" cy="731520"/>
+          </a:xfrm>
+          <a:prstGeom prst="rect">
+            <a:avLst/>
+          </a:prstGeom>
+          <a:noFill/>
+        </p:spPr>
+        <p:txBody>
+          <a:bodyPr wrap="square">
+            <a:spAutoFit/>
+          </a:bodyPr>
+          <a:lstStyle/>
+          <a:p>
+            <a:pPr algn="ctr">
+              <a:lnSpc>
+                <a:spcPts val="4800"/>
+              </a:lnSpc>
+              <a:defRPr sz="4000" b="1">
+                <a:solidFill>
+                  <a:srgbClr val="FFFFFF"/>
+                </a:solidFill>
+                <a:latin typeface="Calibri"/>
+              </a:defRPr>
+            </a:pPr>
+            <a:r>
+              <a:t>1D vs 2D: Complexity Reveals the Truth</a:t>
+            </a:r>
+          </a:p>
+        </p:txBody>
+      </p:sp>
+      <p:sp>
+        <p:nvSpPr>
+          <p:cNvPr id="3" name="Rounded Rectangle 2"/>
+          <p:cNvSpPr/>
+          <p:nvPr/>
+        </p:nvSpPr>
+        <p:spPr>
+          <a:xfrm>
+            <a:off x="731520" y="1371600"/>
+            <a:ext cx="5120640" cy="4754880"/>
+          </a:xfrm>
+          <a:prstGeom prst="roundRect">
+            <a:avLst/>
+          </a:prstGeom>
+          <a:solidFill>
+            <a:srgbClr val="2A2A45"/>
+          </a:solidFill>
+          <a:ln>
+            <a:noFill/>
+          </a:ln>
+        </p:spPr>
+        <p:style>
+          <a:lnRef idx="1">
+            <a:schemeClr val="accent1"/>
+          </a:lnRef>
+          <a:fillRef idx="3">
+            <a:schemeClr val="accent1"/>
+          </a:fillRef>
+          <a:effectRef idx="2">
+            <a:schemeClr val="accent1"/>
+          </a:effectRef>
+          <a:fontRef idx="minor">
+            <a:schemeClr val="lt1"/>
+          </a:fontRef>
+        </p:style>
+        <p:txBody>
+          <a:bodyPr rtlCol="0" anchor="ctr"/>
+          <a:lstStyle/>
+          <a:p>
+            <a:pPr algn="ctr"/>
+          </a:p>
+        </p:txBody>
+      </p:sp>
+      <p:sp>
+        <p:nvSpPr>
+          <p:cNvPr id="4" name="TextBox 3"/>
+          <p:cNvSpPr txBox="1"/>
+          <p:nvPr/>
+        </p:nvSpPr>
+        <p:spPr>
+          <a:xfrm>
+            <a:off x="914400" y="1463040"/>
+            <a:ext cx="4754880" cy="457200"/>
+          </a:xfrm>
+          <a:prstGeom prst="rect">
+            <a:avLst/>
+          </a:prstGeom>
+          <a:noFill/>
+        </p:spPr>
+        <p:txBody>
+          <a:bodyPr wrap="square">
+            <a:spAutoFit/>
+          </a:bodyPr>
+          <a:lstStyle/>
+          <a:p>
+            <a:pPr algn="ctr">
+              <a:lnSpc>
+                <a:spcPts val="2800"/>
+              </a:lnSpc>
+              <a:defRPr sz="2400" b="1">
+                <a:solidFill>
+                  <a:srgbClr val="F08C3A"/>
+                </a:solidFill>
+                <a:latin typeface="Calibri"/>
+              </a:defRPr>
+            </a:pPr>
+            <a:r>
+              <a:t>1D Sine Wave (Simple)</a:t>
+            </a:r>
+          </a:p>
+        </p:txBody>
+      </p:sp>
+      <p:sp>
+        <p:nvSpPr>
+          <p:cNvPr id="5" name="TextBox 4"/>
+          <p:cNvSpPr txBox="1"/>
+          <p:nvPr/>
+        </p:nvSpPr>
+        <p:spPr>
+          <a:xfrm>
+            <a:off x="914400" y="2103120"/>
+            <a:ext cx="4754880" cy="914400"/>
+          </a:xfrm>
+          <a:prstGeom prst="rect">
+            <a:avLst/>
+          </a:prstGeom>
+          <a:noFill/>
+        </p:spPr>
+        <p:txBody>
+          <a:bodyPr wrap="square">
+            <a:spAutoFit/>
+          </a:bodyPr>
+          <a:lstStyle/>
+          <a:p>
+            <a:pPr algn="ctr">
+              <a:lnSpc>
+                <a:spcPts val="2100"/>
+              </a:lnSpc>
+              <a:defRPr sz="1800" b="0">
+                <a:solidFill>
+                  <a:srgbClr val="CCCCCC"/>
+                </a:solidFill>
+                <a:latin typeface="Calibri"/>
+              </a:defRPr>
+            </a:pPr>
+            <a:r>
+              <a:t>123 Q-table entries</a:t>
+            </a:r>
+          </a:p>
+        </p:txBody>
+      </p:sp>
+      <p:graphicFrame>
+        <p:nvGraphicFramePr>
+          <p:cNvPr id="6" name="Table 5"/>
+          <p:cNvGraphicFramePr>
+            <a:graphicFrameLocks noGrp="1"/>
+          </p:cNvGraphicFramePr>
+          <p:nvPr/>
+        </p:nvGraphicFramePr>
+        <p:xfrm>
+          <a:off x="1097280" y="2743200"/>
+          <a:ext cx="4389120" cy="2286000"/>
+        </p:xfrm>
+        <a:graphic>
+          <a:graphicData uri="http://schemas.openxmlformats.org/drawingml/2006/table">
+            <a:tbl>
+              <a:tblPr firstRow="1" bandRow="1">
+                <a:tableStyleId>{5C22544A-7EE6-4342-B048-85BDC9FD1C3A}</a:tableStyleId>
+              </a:tblPr>
+              <a:tblGrid>
+                <a:gridCol w="2194560"/>
+                <a:gridCol w="2194560"/>
+              </a:tblGrid>
+              <a:tr h="571500">
+                <a:tc>
+                  <a:txBody>
+                    <a:bodyPr/>
+                    <a:lstStyle/>
+                    <a:p>
+                      <a:pPr algn="ctr">
+                        <a:defRPr sz="1800" b="1">
+                          <a:solidFill>
+                            <a:srgbClr val="F5C542"/>
+                          </a:solidFill>
+                          <a:latin typeface="Calibri"/>
+                        </a:defRPr>
+                      </a:pPr>
+                      <a:r>
+                        <a:t>Agent</a:t>
+                      </a:r>
+                    </a:p>
+                  </a:txBody>
+                  <a:tcPr>
+                    <a:solidFill>
+                      <a:srgbClr val="333355"/>
+                    </a:solidFill>
+                  </a:tcPr>
+                </a:tc>
+                <a:tc>
+                  <a:txBody>
+                    <a:bodyPr/>
+                    <a:lstStyle/>
+                    <a:p>
+                      <a:pPr algn="ctr">
+                        <a:defRPr sz="1800" b="1">
+                          <a:solidFill>
+                            <a:srgbClr val="F5C542"/>
+                          </a:solidFill>
+                          <a:latin typeface="Calibri"/>
+                        </a:defRPr>
+                      </a:pPr>
+                      <a:r>
+                        <a:t>Eval Error</a:t>
+                      </a:r>
+                    </a:p>
+                  </a:txBody>
+                  <a:tcPr>
+                    <a:solidFill>
+                      <a:srgbClr val="333355"/>
+                    </a:solidFill>
+                  </a:tcPr>
+                </a:tc>
+              </a:tr>
+              <a:tr h="571500">
+                <a:tc>
+                  <a:txBody>
+                    <a:bodyPr/>
+                    <a:lstStyle/>
+                    <a:p>
+                      <a:pPr algn="ctr">
+                        <a:defRPr sz="1800">
+                          <a:solidFill>
+                            <a:srgbClr val="FFFFFF"/>
+                          </a:solidFill>
+                          <a:latin typeface="Calibri"/>
+                        </a:defRPr>
+                      </a:pPr>
+                      <a:r>
+                        <a:t>Baseline</a:t>
+                      </a:r>
+                    </a:p>
+                  </a:txBody>
+                  <a:tcPr>
+                    <a:solidFill>
+                      <a:srgbClr val="282842"/>
+                    </a:solidFill>
+                  </a:tcPr>
+                </a:tc>
+                <a:tc>
+                  <a:txBody>
+                    <a:bodyPr/>
+                    <a:lstStyle/>
+                    <a:p>
+                      <a:pPr algn="ctr">
+                        <a:defRPr sz="1800">
+                          <a:solidFill>
+                            <a:srgbClr val="FFFFFF"/>
+                          </a:solidFill>
+                          <a:latin typeface="Calibri"/>
+                        </a:defRPr>
+                      </a:pPr>
+                      <a:r>
+                        <a:t>0.0858</a:t>
+                      </a:r>
+                    </a:p>
+                  </a:txBody>
+                  <a:tcPr>
+                    <a:solidFill>
+                      <a:srgbClr val="282842"/>
+                    </a:solidFill>
+                  </a:tcPr>
+                </a:tc>
+              </a:tr>
+              <a:tr h="571500">
+                <a:tc>
+                  <a:txBody>
+                    <a:bodyPr/>
+                    <a:lstStyle/>
+                    <a:p>
+                      <a:pPr algn="ctr">
+                        <a:defRPr sz="1800">
+                          <a:solidFill>
+                            <a:srgbClr val="FFFFFF"/>
+                          </a:solidFill>
+                          <a:latin typeface="Calibri"/>
+                        </a:defRPr>
+                      </a:pPr>
+                      <a:r>
+                        <a:t>Naive</a:t>
+                      </a:r>
+                    </a:p>
+                  </a:txBody>
+                  <a:tcPr>
+                    <a:solidFill>
+                      <a:srgbClr val="282842"/>
+                    </a:solidFill>
+                  </a:tcPr>
+                </a:tc>
+                <a:tc>
+                  <a:txBody>
+                    <a:bodyPr/>
+                    <a:lstStyle/>
+                    <a:p>
+                      <a:pPr algn="ctr">
+                        <a:defRPr sz="1800">
+                          <a:solidFill>
+                            <a:srgbClr val="FFFFFF"/>
+                          </a:solidFill>
+                          <a:latin typeface="Calibri"/>
+                        </a:defRPr>
+                      </a:pPr>
+                      <a:r>
+                        <a:t>0.1236</a:t>
+                      </a:r>
+                    </a:p>
+                  </a:txBody>
+                  <a:tcPr>
+                    <a:solidFill>
+                      <a:srgbClr val="282842"/>
+                    </a:solidFill>
+                  </a:tcPr>
+                </a:tc>
+              </a:tr>
+              <a:tr h="571500">
+                <a:tc>
+                  <a:txBody>
+                    <a:bodyPr/>
+                    <a:lstStyle/>
+                    <a:p>
+                      <a:pPr algn="ctr">
+                        <a:defRPr sz="1800">
+                          <a:solidFill>
+                            <a:srgbClr val="FFFFFF"/>
+                          </a:solidFill>
+                          <a:latin typeface="Calibri"/>
+                        </a:defRPr>
+                      </a:pPr>
+                      <a:r>
+                        <a:t>Dropout-Aware</a:t>
+                      </a:r>
+                    </a:p>
+                  </a:txBody>
+                  <a:tcPr>
+                    <a:solidFill>
+                      <a:srgbClr val="282842"/>
+                    </a:solidFill>
+                  </a:tcPr>
+                </a:tc>
+                <a:tc>
+                  <a:txBody>
+                    <a:bodyPr/>
+                    <a:lstStyle/>
+                    <a:p>
+                      <a:pPr algn="ctr">
+                        <a:defRPr sz="1800">
+                          <a:solidFill>
+                            <a:srgbClr val="FFFFFF"/>
+                          </a:solidFill>
+                          <a:latin typeface="Calibri"/>
+                        </a:defRPr>
+                      </a:pPr>
+                      <a:r>
+                        <a:t>0.1236</a:t>
+                      </a:r>
+                    </a:p>
+                  </a:txBody>
+                  <a:tcPr>
+                    <a:solidFill>
+                      <a:srgbClr val="282842"/>
+                    </a:solidFill>
+                  </a:tcPr>
+                </a:tc>
+              </a:tr>
+            </a:tbl>
+          </a:graphicData>
+        </a:graphic>
+      </p:graphicFrame>
+      <p:sp>
+        <p:nvSpPr>
+          <p:cNvPr id="7" name="TextBox 6"/>
+          <p:cNvSpPr txBox="1"/>
+          <p:nvPr/>
+        </p:nvSpPr>
+        <p:spPr>
+          <a:xfrm>
+            <a:off x="914400" y="5212080"/>
+            <a:ext cx="4754880" cy="731520"/>
+          </a:xfrm>
+          <a:prstGeom prst="rect">
+            <a:avLst/>
+          </a:prstGeom>
+          <a:noFill/>
+        </p:spPr>
+        <p:txBody>
+          <a:bodyPr wrap="square">
+            <a:spAutoFit/>
+          </a:bodyPr>
+          <a:lstStyle/>
+          <a:p>
+            <a:pPr algn="ctr">
+              <a:lnSpc>
+                <a:spcPts val="2100"/>
+              </a:lnSpc>
+              <a:defRPr sz="1800" b="1">
+                <a:solidFill>
+                  <a:srgbClr val="F08C3A"/>
+                </a:solidFill>
+                <a:latin typeface="Calibri"/>
+              </a:defRPr>
+            </a:pPr>
+            <a:r>
+              <a:t>Naive = Dropout-Aware</a:t>
+            </a:r>
+            <a:br/>
+            <a:r>
+              <a:t>Same policy, no visible difference</a:t>
+            </a:r>
+          </a:p>
+        </p:txBody>
+      </p:sp>
+      <p:sp>
+        <p:nvSpPr>
+          <p:cNvPr id="8" name="Rounded Rectangle 7"/>
+          <p:cNvSpPr/>
+          <p:nvPr/>
+        </p:nvSpPr>
+        <p:spPr>
+          <a:xfrm>
+            <a:off x="6217920" y="1371600"/>
+            <a:ext cx="5303520" cy="4754880"/>
+          </a:xfrm>
+          <a:prstGeom prst="roundRect">
+            <a:avLst/>
+          </a:prstGeom>
+          <a:solidFill>
+            <a:srgbClr val="2A2A45"/>
+          </a:solidFill>
+          <a:ln>
+            <a:noFill/>
+          </a:ln>
+        </p:spPr>
+        <p:style>
+          <a:lnRef idx="1">
+            <a:schemeClr val="accent1"/>
+          </a:lnRef>
+          <a:fillRef idx="3">
+            <a:schemeClr val="accent1"/>
+          </a:fillRef>
+          <a:effectRef idx="2">
+            <a:schemeClr val="accent1"/>
+          </a:effectRef>
+          <a:fontRef idx="minor">
+            <a:schemeClr val="lt1"/>
+          </a:fontRef>
+        </p:style>
+        <p:txBody>
+          <a:bodyPr rtlCol="0" anchor="ctr"/>
+          <a:lstStyle/>
+          <a:p>
+            <a:pPr algn="ctr"/>
+          </a:p>
+        </p:txBody>
+      </p:sp>
+      <p:sp>
+        <p:nvSpPr>
+          <p:cNvPr id="9" name="TextBox 8"/>
+          <p:cNvSpPr txBox="1"/>
+          <p:nvPr/>
+        </p:nvSpPr>
+        <p:spPr>
+          <a:xfrm>
+            <a:off x="6400800" y="1463040"/>
+            <a:ext cx="4937760" cy="457200"/>
+          </a:xfrm>
+          <a:prstGeom prst="rect">
+            <a:avLst/>
+          </a:prstGeom>
+          <a:noFill/>
+        </p:spPr>
+        <p:txBody>
+          <a:bodyPr wrap="square">
+            <a:spAutoFit/>
+          </a:bodyPr>
+          <a:lstStyle/>
+          <a:p>
+            <a:pPr algn="ctr">
+              <a:lnSpc>
+                <a:spcPts val="2800"/>
+              </a:lnSpc>
+              <a:defRPr sz="2400" b="1">
+                <a:solidFill>
+                  <a:srgbClr val="4EC98B"/>
+                </a:solidFill>
+                <a:latin typeface="Calibri"/>
+              </a:defRPr>
+            </a:pPr>
+            <a:r>
+              <a:t>2D Figure-Eight (Complex)</a:t>
+            </a:r>
+          </a:p>
+        </p:txBody>
+      </p:sp>
+      <p:sp>
+        <p:nvSpPr>
+          <p:cNvPr id="10" name="TextBox 9"/>
+          <p:cNvSpPr txBox="1"/>
+          <p:nvPr/>
+        </p:nvSpPr>
+        <p:spPr>
+          <a:xfrm>
+            <a:off x="6400800" y="2103120"/>
+            <a:ext cx="4937760" cy="914400"/>
+          </a:xfrm>
+          <a:prstGeom prst="rect">
+            <a:avLst/>
+          </a:prstGeom>
+          <a:noFill/>
+        </p:spPr>
+        <p:txBody>
+          <a:bodyPr wrap="square">
+            <a:spAutoFit/>
+          </a:bodyPr>
+          <a:lstStyle/>
+          <a:p>
+            <a:pPr algn="ctr">
+              <a:lnSpc>
+                <a:spcPts val="2100"/>
+              </a:lnSpc>
+              <a:defRPr sz="1800" b="0">
+                <a:solidFill>
+                  <a:srgbClr val="CCCCCC"/>
+                </a:solidFill>
+                <a:latin typeface="Calibri"/>
+              </a:defRPr>
+            </a:pPr>
+            <a:r>
+              <a:t>3,969 Q-table entries (32x larger)</a:t>
+            </a:r>
+          </a:p>
+        </p:txBody>
+      </p:sp>
+      <p:graphicFrame>
+        <p:nvGraphicFramePr>
+          <p:cNvPr id="11" name="Table 10"/>
+          <p:cNvGraphicFramePr>
+            <a:graphicFrameLocks noGrp="1"/>
+          </p:cNvGraphicFramePr>
+          <p:nvPr/>
+        </p:nvGraphicFramePr>
+        <p:xfrm>
+          <a:off x="6583680" y="2743200"/>
+          <a:ext cx="4572000" cy="2286000"/>
+        </p:xfrm>
+        <a:graphic>
+          <a:graphicData uri="http://schemas.openxmlformats.org/drawingml/2006/table">
+            <a:tbl>
+              <a:tblPr firstRow="1" bandRow="1">
+                <a:tableStyleId>{5C22544A-7EE6-4342-B048-85BDC9FD1C3A}</a:tableStyleId>
+              </a:tblPr>
+              <a:tblGrid>
+                <a:gridCol w="2286000"/>
+                <a:gridCol w="2286000"/>
+              </a:tblGrid>
+              <a:tr h="571500">
+                <a:tc>
+                  <a:txBody>
+                    <a:bodyPr/>
+                    <a:lstStyle/>
+                    <a:p>
+                      <a:pPr algn="ctr">
+                        <a:defRPr sz="1800" b="1">
+                          <a:solidFill>
+                            <a:srgbClr val="F5C542"/>
+                          </a:solidFill>
+                          <a:latin typeface="Calibri"/>
+                        </a:defRPr>
+                      </a:pPr>
+                      <a:r>
+                        <a:t>Agent</a:t>
+                      </a:r>
+                    </a:p>
+                  </a:txBody>
+                  <a:tcPr>
+                    <a:solidFill>
+                      <a:srgbClr val="333355"/>
+                    </a:solidFill>
+                  </a:tcPr>
+                </a:tc>
+                <a:tc>
+                  <a:txBody>
+                    <a:bodyPr/>
+                    <a:lstStyle/>
+                    <a:p>
+                      <a:pPr algn="ctr">
+                        <a:defRPr sz="1800" b="1">
+                          <a:solidFill>
+                            <a:srgbClr val="F5C542"/>
+                          </a:solidFill>
+                          <a:latin typeface="Calibri"/>
+                        </a:defRPr>
+                      </a:pPr>
+                      <a:r>
+                        <a:t>Eval Error</a:t>
+                      </a:r>
+                    </a:p>
+                  </a:txBody>
+                  <a:tcPr>
+                    <a:solidFill>
+                      <a:srgbClr val="333355"/>
+                    </a:solidFill>
+                  </a:tcPr>
+                </a:tc>
+              </a:tr>
+              <a:tr h="571500">
+                <a:tc>
+                  <a:txBody>
+                    <a:bodyPr/>
+                    <a:lstStyle/>
+                    <a:p>
+                      <a:pPr algn="ctr">
+                        <a:defRPr sz="1800">
+                          <a:solidFill>
+                            <a:srgbClr val="FFFFFF"/>
+                          </a:solidFill>
+                          <a:latin typeface="Calibri"/>
+                        </a:defRPr>
+                      </a:pPr>
+                      <a:r>
+                        <a:t>Baseline (no drop)</a:t>
+                      </a:r>
+                    </a:p>
+                  </a:txBody>
+                  <a:tcPr>
+                    <a:solidFill>
+                      <a:srgbClr val="282842"/>
+                    </a:solidFill>
+                  </a:tcPr>
+                </a:tc>
+                <a:tc>
+                  <a:txBody>
+                    <a:bodyPr/>
+                    <a:lstStyle/>
+                    <a:p>
+                      <a:pPr algn="ctr">
+                        <a:defRPr sz="1800">
+                          <a:solidFill>
+                            <a:srgbClr val="FFFFFF"/>
+                          </a:solidFill>
+                          <a:latin typeface="Calibri"/>
+                        </a:defRPr>
+                      </a:pPr>
+                      <a:r>
+                        <a:t>0.2373</a:t>
+                      </a:r>
+                    </a:p>
+                  </a:txBody>
+                  <a:tcPr>
+                    <a:solidFill>
+                      <a:srgbClr val="282842"/>
+                    </a:solidFill>
+                  </a:tcPr>
+                </a:tc>
+              </a:tr>
+              <a:tr h="571500">
+                <a:tc>
+                  <a:txBody>
+                    <a:bodyPr/>
+                    <a:lstStyle/>
+                    <a:p>
+                      <a:pPr algn="ctr">
+                        <a:defRPr sz="1800">
+                          <a:solidFill>
+                            <a:srgbClr val="FFFFFF"/>
+                          </a:solidFill>
+                          <a:latin typeface="Calibri"/>
+                        </a:defRPr>
+                      </a:pPr>
+                      <a:r>
+                        <a:t>Naive (30% drop)</a:t>
+                      </a:r>
+                    </a:p>
+                  </a:txBody>
+                  <a:tcPr>
+                    <a:solidFill>
+                      <a:srgbClr val="282842"/>
+                    </a:solidFill>
+                  </a:tcPr>
+                </a:tc>
+                <a:tc>
+                  <a:txBody>
+                    <a:bodyPr/>
+                    <a:lstStyle/>
+                    <a:p>
+                      <a:pPr algn="ctr">
+                        <a:defRPr sz="1800">
+                          <a:solidFill>
+                            <a:srgbClr val="FFFFFF"/>
+                          </a:solidFill>
+                          <a:latin typeface="Calibri"/>
+                        </a:defRPr>
+                      </a:pPr>
+                      <a:r>
+                        <a:t>0.4413</a:t>
+                      </a:r>
+                    </a:p>
+                  </a:txBody>
+                  <a:tcPr>
+                    <a:solidFill>
+                      <a:srgbClr val="282842"/>
+                    </a:solidFill>
+                  </a:tcPr>
+                </a:tc>
+              </a:tr>
+              <a:tr h="571500">
+                <a:tc>
+                  <a:txBody>
+                    <a:bodyPr/>
+                    <a:lstStyle/>
+                    <a:p>
+                      <a:pPr algn="ctr">
+                        <a:defRPr sz="1800" b="1">
+                          <a:solidFill>
+                            <a:srgbClr val="4EC98B"/>
+                          </a:solidFill>
+                          <a:latin typeface="Calibri"/>
+                        </a:defRPr>
+                      </a:pPr>
+                      <a:r>
+                        <a:t>Dropout-Aware</a:t>
+                      </a:r>
+                    </a:p>
+                  </a:txBody>
+                  <a:tcPr>
+                    <a:solidFill>
+                      <a:srgbClr val="282842"/>
+                    </a:solidFill>
+                  </a:tcPr>
+                </a:tc>
+                <a:tc>
+                  <a:txBody>
+                    <a:bodyPr/>
+                    <a:lstStyle/>
+                    <a:p>
+                      <a:pPr algn="ctr">
+                        <a:defRPr sz="1800" b="1">
+                          <a:solidFill>
+                            <a:srgbClr val="4EC98B"/>
+                          </a:solidFill>
+                          <a:latin typeface="Calibri"/>
+                        </a:defRPr>
+                      </a:pPr>
+                      <a:r>
+                        <a:t>0.3730</a:t>
+                      </a:r>
+                    </a:p>
+                  </a:txBody>
+                  <a:tcPr>
+                    <a:solidFill>
+                      <a:srgbClr val="282842"/>
+                    </a:solidFill>
+                  </a:tcPr>
+                </a:tc>
+              </a:tr>
+            </a:tbl>
+          </a:graphicData>
+        </a:graphic>
+      </p:graphicFrame>
+      <p:sp>
+        <p:nvSpPr>
+          <p:cNvPr id="12" name="TextBox 11"/>
+          <p:cNvSpPr txBox="1"/>
+          <p:nvPr/>
+        </p:nvSpPr>
+        <p:spPr>
+          <a:xfrm>
+            <a:off x="6400800" y="5212080"/>
+            <a:ext cx="4937760" cy="731520"/>
+          </a:xfrm>
+          <a:prstGeom prst="rect">
+            <a:avLst/>
+          </a:prstGeom>
+          <a:noFill/>
+        </p:spPr>
+        <p:txBody>
+          <a:bodyPr wrap="square">
+            <a:spAutoFit/>
+          </a:bodyPr>
+          <a:lstStyle/>
+          <a:p>
+            <a:pPr algn="ctr">
+              <a:lnSpc>
+                <a:spcPts val="2100"/>
+              </a:lnSpc>
+              <a:defRPr sz="1800" b="1">
+                <a:solidFill>
+                  <a:srgbClr val="4EC98B"/>
+                </a:solidFill>
+                <a:latin typeface="Calibri"/>
+              </a:defRPr>
+            </a:pPr>
+            <a:r>
+              <a:t>Dropout-Aware BEATS Naive by 15.5%</a:t>
+            </a:r>
+            <a:br/>
+            <a:r>
+              <a:t>Complexity reveals the real advantage</a:t>
+            </a:r>
+          </a:p>
+        </p:txBody>
+      </p:sp>
+    </p:spTree>
+  </p:cSld>
+  <p:clrMapOvr>
+    <a:masterClrMapping/>
+  </p:clrMapOvr>
+</p:sld>
+</file>
+
+<file path=ppt/slides/slide23.xml><?xml version="1.0" encoding="utf-8"?>
+<p:sld xmlns:a="http://schemas.openxmlformats.org/drawingml/2006/main" xmlns:p="http://schemas.openxmlformats.org/presentationml/2006/main" xmlns:r="http://schemas.openxmlformats.org/officeDocument/2006/relationships">
+  <p:cSld>
+    <p:bg>
+      <p:bgPr>
+        <a:solidFill>
+          <a:srgbClr val="1A1A2E"/>
+        </a:solidFill>
+        <a:effectLst/>
+      </p:bgPr>
+    </p:bg>
+    <p:spTree>
+      <p:nvGrpSpPr>
+        <p:cNvPr id="1" name=""/>
+        <p:cNvGrpSpPr/>
+        <p:nvPr/>
+      </p:nvGrpSpPr>
+      <p:grpSpPr/>
+      <p:sp>
+        <p:nvSpPr>
+          <p:cNvPr id="2" name="TextBox 1"/>
+          <p:cNvSpPr txBox="1"/>
+          <p:nvPr/>
+        </p:nvSpPr>
+        <p:spPr>
+          <a:xfrm>
+            <a:off x="731520" y="274320"/>
+            <a:ext cx="10515600" cy="731520"/>
+          </a:xfrm>
+          <a:prstGeom prst="rect">
+            <a:avLst/>
+          </a:prstGeom>
+          <a:noFill/>
+        </p:spPr>
+        <p:txBody>
+          <a:bodyPr wrap="square">
+            <a:spAutoFit/>
+          </a:bodyPr>
+          <a:lstStyle/>
+          <a:p>
+            <a:pPr algn="ctr">
+              <a:lnSpc>
+                <a:spcPts val="5200"/>
+              </a:lnSpc>
+              <a:defRPr sz="4400" b="1">
+                <a:solidFill>
+                  <a:srgbClr val="FFFFFF"/>
+                </a:solidFill>
+                <a:latin typeface="Calibri"/>
+              </a:defRPr>
+            </a:pPr>
+            <a:r>
+              <a:t>Three Takeaways</a:t>
+            </a:r>
+          </a:p>
+        </p:txBody>
+      </p:sp>
+      <p:sp>
+        <p:nvSpPr>
+          <p:cNvPr id="3" name="Rounded Rectangle 2"/>
+          <p:cNvSpPr/>
+          <p:nvPr/>
+        </p:nvSpPr>
+        <p:spPr>
+          <a:xfrm>
+            <a:off x="914400" y="1371600"/>
+            <a:ext cx="731520" cy="731520"/>
+          </a:xfrm>
+          <a:prstGeom prst="roundRect">
+            <a:avLst/>
+          </a:prstGeom>
+          <a:solidFill>
+            <a:srgbClr val="4EC98B"/>
+          </a:solidFill>
+          <a:ln>
+            <a:noFill/>
+          </a:ln>
+        </p:spPr>
+        <p:style>
+          <a:lnRef idx="1">
+            <a:schemeClr val="accent1"/>
+          </a:lnRef>
+          <a:fillRef idx="3">
+            <a:schemeClr val="accent1"/>
+          </a:fillRef>
+          <a:effectRef idx="2">
+            <a:schemeClr val="accent1"/>
+          </a:effectRef>
+          <a:fontRef idx="minor">
+            <a:schemeClr val="lt1"/>
+          </a:fontRef>
+        </p:style>
+        <p:txBody>
+          <a:bodyPr rtlCol="0" anchor="ctr" wrap="square"/>
+          <a:lstStyle/>
+          <a:p>
+            <a:pPr algn="ctr">
+              <a:defRPr sz="3200" b="1">
+                <a:solidFill>
+                  <a:srgbClr val="1A1A2E"/>
+                </a:solidFill>
+                <a:latin typeface="Calibri"/>
+              </a:defRPr>
+            </a:pPr>
+            <a:r>
+              <a:t>1</a:t>
+            </a:r>
+          </a:p>
+        </p:txBody>
+      </p:sp>
+      <p:sp>
+        <p:nvSpPr>
+          <p:cNvPr id="4" name="TextBox 3"/>
+          <p:cNvSpPr txBox="1"/>
+          <p:nvPr/>
+        </p:nvSpPr>
+        <p:spPr>
+          <a:xfrm>
+            <a:off x="1920240" y="1371600"/>
+            <a:ext cx="9144000" cy="548640"/>
+          </a:xfrm>
+          <a:prstGeom prst="rect">
+            <a:avLst/>
+          </a:prstGeom>
+          <a:noFill/>
+        </p:spPr>
+        <p:txBody>
+          <a:bodyPr wrap="square">
+            <a:spAutoFit/>
+          </a:bodyPr>
+          <a:lstStyle/>
+          <a:p>
+            <a:pPr algn="l">
+              <a:lnSpc>
+                <a:spcPts val="3300"/>
+              </a:lnSpc>
+              <a:defRPr sz="2800" b="1">
+                <a:solidFill>
+                  <a:srgbClr val="4EC98B"/>
+                </a:solidFill>
+                <a:latin typeface="Calibri"/>
+              </a:defRPr>
+            </a:pPr>
+            <a:r>
+              <a:t>When in doubt, don't act.</a:t>
+            </a:r>
+          </a:p>
+        </p:txBody>
+      </p:sp>
+      <p:sp>
+        <p:nvSpPr>
+          <p:cNvPr id="5" name="TextBox 4"/>
+          <p:cNvSpPr txBox="1"/>
+          <p:nvPr/>
+        </p:nvSpPr>
+        <p:spPr>
+          <a:xfrm>
+            <a:off x="1920240" y="2011680"/>
+            <a:ext cx="9144000" cy="914400"/>
+          </a:xfrm>
+          <a:prstGeom prst="rect">
+            <a:avLst/>
+          </a:prstGeom>
+          <a:noFill/>
+        </p:spPr>
+        <p:txBody>
+          <a:bodyPr wrap="square">
+            <a:spAutoFit/>
+          </a:bodyPr>
+          <a:lstStyle/>
+          <a:p>
+            <a:pPr algn="l">
+              <a:lnSpc>
+                <a:spcPts val="2300"/>
+              </a:lnSpc>
+              <a:defRPr sz="1800" b="0">
+                <a:solidFill>
+                  <a:srgbClr val="CCCCCC"/>
+                </a:solidFill>
+                <a:latin typeface="Calibri"/>
+              </a:defRPr>
+            </a:pPr>
+            <a:r>
+              <a:t>Acting on bad information is worse than waiting.</a:t>
+            </a:r>
+            <a:br/>
+            <a:r>
+              <a:t>The dropout-aware agent improved by simply skipping uncertain updates.</a:t>
+            </a:r>
+          </a:p>
+        </p:txBody>
+      </p:sp>
+      <p:sp>
+        <p:nvSpPr>
+          <p:cNvPr id="6" name="Rounded Rectangle 5"/>
+          <p:cNvSpPr/>
+          <p:nvPr/>
+        </p:nvSpPr>
+        <p:spPr>
+          <a:xfrm>
+            <a:off x="914400" y="3108960"/>
+            <a:ext cx="731520" cy="731520"/>
+          </a:xfrm>
+          <a:prstGeom prst="roundRect">
+            <a:avLst/>
+          </a:prstGeom>
+          <a:solidFill>
+            <a:srgbClr val="4D9DE8"/>
+          </a:solidFill>
+          <a:ln>
+            <a:noFill/>
+          </a:ln>
+        </p:spPr>
+        <p:style>
+          <a:lnRef idx="1">
+            <a:schemeClr val="accent1"/>
+          </a:lnRef>
+          <a:fillRef idx="3">
+            <a:schemeClr val="accent1"/>
+          </a:fillRef>
+          <a:effectRef idx="2">
+            <a:schemeClr val="accent1"/>
+          </a:effectRef>
+          <a:fontRef idx="minor">
+            <a:schemeClr val="lt1"/>
+          </a:fontRef>
+        </p:style>
+        <p:txBody>
+          <a:bodyPr rtlCol="0" anchor="ctr" wrap="square"/>
+          <a:lstStyle/>
+          <a:p>
+            <a:pPr algn="ctr">
+              <a:defRPr sz="3200" b="1">
+                <a:solidFill>
+                  <a:srgbClr val="1A1A2E"/>
+                </a:solidFill>
+                <a:latin typeface="Calibri"/>
+              </a:defRPr>
+            </a:pPr>
+            <a:r>
+              <a:t>2</a:t>
+            </a:r>
+          </a:p>
+        </p:txBody>
+      </p:sp>
+      <p:sp>
+        <p:nvSpPr>
+          <p:cNvPr id="7" name="TextBox 6"/>
+          <p:cNvSpPr txBox="1"/>
+          <p:nvPr/>
+        </p:nvSpPr>
+        <p:spPr>
+          <a:xfrm>
+            <a:off x="1920240" y="3108960"/>
+            <a:ext cx="9144000" cy="548640"/>
+          </a:xfrm>
+          <a:prstGeom prst="rect">
+            <a:avLst/>
+          </a:prstGeom>
+          <a:noFill/>
+        </p:spPr>
+        <p:txBody>
+          <a:bodyPr wrap="square">
+            <a:spAutoFit/>
+          </a:bodyPr>
+          <a:lstStyle/>
+          <a:p>
+            <a:pPr algn="l">
+              <a:lnSpc>
+                <a:spcPts val="3300"/>
+              </a:lnSpc>
+              <a:defRPr sz="2800" b="1">
+                <a:solidFill>
+                  <a:srgbClr val="4D9DE8"/>
+                </a:solidFill>
+                <a:latin typeface="Calibri"/>
+              </a:defRPr>
+            </a:pPr>
+            <a:r>
+              <a:t>Simple beats clever.</a:t>
+            </a:r>
+          </a:p>
+        </p:txBody>
+      </p:sp>
+      <p:sp>
+        <p:nvSpPr>
+          <p:cNvPr id="8" name="TextBox 7"/>
+          <p:cNvSpPr txBox="1"/>
+          <p:nvPr/>
+        </p:nvSpPr>
+        <p:spPr>
+          <a:xfrm>
+            <a:off x="1920240" y="3749040"/>
+            <a:ext cx="9144000" cy="914400"/>
+          </a:xfrm>
+          <a:prstGeom prst="rect">
+            <a:avLst/>
+          </a:prstGeom>
+          <a:noFill/>
+        </p:spPr>
+        <p:txBody>
+          <a:bodyPr wrap="square">
+            <a:spAutoFit/>
+          </a:bodyPr>
+          <a:lstStyle/>
+          <a:p>
+            <a:pPr algn="l">
+              <a:lnSpc>
+                <a:spcPts val="2300"/>
+              </a:lnSpc>
+              <a:defRPr sz="1800" b="0">
+                <a:solidFill>
+                  <a:srgbClr val="CCCCCC"/>
+                </a:solidFill>
+                <a:latin typeface="Calibri"/>
+              </a:defRPr>
+            </a:pPr>
+            <a:r>
+              <a:t>A sophisticated state estimator made things worse.</a:t>
+            </a:r>
+            <a:br/>
+            <a:r>
+              <a:t>The best strategy was the most obvious one.</a:t>
+            </a:r>
+          </a:p>
+        </p:txBody>
+      </p:sp>
+      <p:sp>
+        <p:nvSpPr>
+          <p:cNvPr id="9" name="Rounded Rectangle 8"/>
+          <p:cNvSpPr/>
+          <p:nvPr/>
+        </p:nvSpPr>
+        <p:spPr>
+          <a:xfrm>
+            <a:off x="914400" y="4846320"/>
+            <a:ext cx="731520" cy="731520"/>
+          </a:xfrm>
+          <a:prstGeom prst="roundRect">
+            <a:avLst/>
+          </a:prstGeom>
+          <a:solidFill>
+            <a:srgbClr val="F08C3A"/>
+          </a:solidFill>
+          <a:ln>
+            <a:noFill/>
+          </a:ln>
+        </p:spPr>
+        <p:style>
+          <a:lnRef idx="1">
+            <a:schemeClr val="accent1"/>
+          </a:lnRef>
+          <a:fillRef idx="3">
+            <a:schemeClr val="accent1"/>
+          </a:fillRef>
+          <a:effectRef idx="2">
+            <a:schemeClr val="accent1"/>
+          </a:effectRef>
+          <a:fontRef idx="minor">
+            <a:schemeClr val="lt1"/>
+          </a:fontRef>
+        </p:style>
+        <p:txBody>
+          <a:bodyPr rtlCol="0" anchor="ctr" wrap="square"/>
+          <a:lstStyle/>
+          <a:p>
+            <a:pPr algn="ctr">
+              <a:defRPr sz="3200" b="1">
+                <a:solidFill>
+                  <a:srgbClr val="1A1A2E"/>
+                </a:solidFill>
+                <a:latin typeface="Calibri"/>
+              </a:defRPr>
+            </a:pPr>
+            <a:r>
+              <a:t>3</a:t>
+            </a:r>
+          </a:p>
+        </p:txBody>
+      </p:sp>
+      <p:sp>
+        <p:nvSpPr>
+          <p:cNvPr id="10" name="TextBox 9"/>
+          <p:cNvSpPr txBox="1"/>
+          <p:nvPr/>
+        </p:nvSpPr>
+        <p:spPr>
+          <a:xfrm>
+            <a:off x="1920240" y="4846320"/>
+            <a:ext cx="9144000" cy="548640"/>
+          </a:xfrm>
+          <a:prstGeom prst="rect">
+            <a:avLst/>
+          </a:prstGeom>
+          <a:noFill/>
+        </p:spPr>
+        <p:txBody>
+          <a:bodyPr wrap="square">
+            <a:spAutoFit/>
+          </a:bodyPr>
+          <a:lstStyle/>
+          <a:p>
+            <a:pPr algn="l">
+              <a:lnSpc>
+                <a:spcPts val="3300"/>
+              </a:lnSpc>
+              <a:defRPr sz="2800" b="1">
+                <a:solidFill>
+                  <a:srgbClr val="F08C3A"/>
+                </a:solidFill>
+                <a:latin typeface="Calibri"/>
+              </a:defRPr>
+            </a:pPr>
+            <a:r>
+              <a:t>You don't need to define the goal.</a:t>
+            </a:r>
+          </a:p>
+        </p:txBody>
+      </p:sp>
+      <p:sp>
+        <p:nvSpPr>
+          <p:cNvPr id="11" name="TextBox 10"/>
+          <p:cNvSpPr txBox="1"/>
+          <p:nvPr/>
+        </p:nvSpPr>
+        <p:spPr>
+          <a:xfrm>
+            <a:off x="1920240" y="5486400"/>
+            <a:ext cx="9144000" cy="914400"/>
+          </a:xfrm>
+          <a:prstGeom prst="rect">
+            <a:avLst/>
+          </a:prstGeom>
+          <a:noFill/>
+        </p:spPr>
+        <p:txBody>
+          <a:bodyPr wrap="square">
+            <a:spAutoFit/>
+          </a:bodyPr>
+          <a:lstStyle/>
+          <a:p>
+            <a:pPr algn="l">
+              <a:lnSpc>
+                <a:spcPts val="2300"/>
+              </a:lnSpc>
+              <a:defRPr sz="1800" b="0">
+                <a:solidFill>
+                  <a:srgbClr val="CCCCCC"/>
+                </a:solidFill>
+                <a:latin typeface="Calibri"/>
+              </a:defRPr>
+            </a:pPr>
+            <a:r>
+              <a:t>Inverse RL discovered the reward from expert demonstrations alone.</a:t>
+            </a:r>
+            <a:br/>
+            <a:r>
+              <a:t>The objective reveals itself through behavior.</a:t>
+            </a:r>
+          </a:p>
+        </p:txBody>
+      </p:sp>
+    </p:spTree>
+  </p:cSld>
+  <p:clrMapOvr>
+    <a:masterClrMapping/>
+  </p:clrMapOvr>
+</p:sld>
+</file>
+
+<file path=ppt/slides/slide24.xml><?xml version="1.0" encoding="utf-8"?>
+<p:sld xmlns:a="http://schemas.openxmlformats.org/drawingml/2006/main" xmlns:p="http://schemas.openxmlformats.org/presentationml/2006/main" xmlns:r="http://schemas.openxmlformats.org/officeDocument/2006/relationships">
+  <p:cSld>
+    <p:bg>
+      <p:bgPr>
+        <a:solidFill>
+          <a:srgbClr val="1A1A2E"/>
+        </a:solidFill>
+        <a:effectLst/>
+      </p:bgPr>
+    </p:bg>
+    <p:spTree>
+      <p:nvGrpSpPr>
+        <p:cNvPr id="1" name=""/>
+        <p:cNvGrpSpPr/>
+        <p:nvPr/>
+      </p:nvGrpSpPr>
+      <p:grpSpPr/>
+      <p:sp>
+        <p:nvSpPr>
+          <p:cNvPr id="2" name="TextBox 1"/>
+          <p:cNvSpPr txBox="1"/>
+          <p:nvPr/>
+        </p:nvSpPr>
+        <p:spPr>
+          <a:xfrm>
+            <a:off x="914400" y="914400"/>
+            <a:ext cx="10058400" cy="1828800"/>
+          </a:xfrm>
+          <a:prstGeom prst="rect">
+            <a:avLst/>
+          </a:prstGeom>
+          <a:noFill/>
+        </p:spPr>
+        <p:txBody>
+          <a:bodyPr wrap="square">
+            <a:spAutoFit/>
+          </a:bodyPr>
+          <a:lstStyle/>
+          <a:p>
+            <a:pPr algn="ctr">
+              <a:lnSpc>
+                <a:spcPts val="5400"/>
+              </a:lnSpc>
+              <a:defRPr sz="3600" b="0">
+                <a:solidFill>
+                  <a:srgbClr val="CCCCCC"/>
+                </a:solidFill>
+                <a:latin typeface="Calibri"/>
+              </a:defRPr>
+            </a:pPr>
+            <a:r>
+              <a:t>The next time a robot loses signal</a:t>
+            </a:r>
+            <a:br/>
+            <a:r>
+              <a:t>mid-operation...</a:t>
+            </a:r>
+          </a:p>
+        </p:txBody>
+      </p:sp>
+      <p:sp>
+        <p:nvSpPr>
+          <p:cNvPr id="3" name="TextBox 2"/>
+          <p:cNvSpPr txBox="1"/>
+          <p:nvPr/>
+        </p:nvSpPr>
+        <p:spPr>
+          <a:xfrm>
+            <a:off x="914400" y="2926080"/>
+            <a:ext cx="10058400" cy="2286000"/>
+          </a:xfrm>
+          <a:prstGeom prst="rect">
+            <a:avLst/>
+          </a:prstGeom>
+          <a:noFill/>
+        </p:spPr>
+        <p:txBody>
+          <a:bodyPr wrap="square">
+            <a:spAutoFit/>
+          </a:bodyPr>
+          <a:lstStyle/>
+          <a:p>
+            <a:pPr algn="ctr">
+              <a:lnSpc>
+                <a:spcPts val="5400"/>
+              </a:lnSpc>
+              <a:defRPr sz="3600" b="0">
+                <a:solidFill>
+                  <a:srgbClr val="FFFFFF"/>
+                </a:solidFill>
+                <a:latin typeface="Calibri"/>
+              </a:defRPr>
+            </a:pPr>
+            <a:r>
+              <a:t>the smartest thing it can do</a:t>
+            </a:r>
+            <a:br/>
+            <a:r>
+              <a:t>might be the simplest:</a:t>
+            </a:r>
+          </a:p>
+        </p:txBody>
+      </p:sp>
+      <p:sp>
+        <p:nvSpPr>
+          <p:cNvPr id="4" name="TextBox 3"/>
+          <p:cNvSpPr txBox="1"/>
+          <p:nvPr/>
+        </p:nvSpPr>
+        <p:spPr>
+          <a:xfrm>
+            <a:off x="914400" y="4572000"/>
+            <a:ext cx="10058400" cy="1371600"/>
+          </a:xfrm>
+          <a:prstGeom prst="rect">
+            <a:avLst/>
+          </a:prstGeom>
+          <a:noFill/>
+        </p:spPr>
+        <p:txBody>
+          <a:bodyPr wrap="square">
+            <a:spAutoFit/>
+          </a:bodyPr>
+          <a:lstStyle/>
+          <a:p>
+            <a:pPr algn="ctr">
+              <a:lnSpc>
+                <a:spcPts val="5600"/>
+              </a:lnSpc>
+              <a:defRPr sz="4000" b="1">
+                <a:solidFill>
+                  <a:srgbClr val="F5C542"/>
+                </a:solidFill>
+                <a:latin typeface="Calibri"/>
+              </a:defRPr>
+            </a:pPr>
+            <a:r>
+              <a:t>Put down the scalpel.</a:t>
+            </a:r>
+            <a:br/>
+            <a:r>
+              <a:t>Wait for a clear picture.</a:t>
+            </a:r>
+            <a:br/>
+            <a:r>
+              <a:t>Then cut.</a:t>
+            </a:r>
+          </a:p>
+        </p:txBody>
+      </p:sp>
+    </p:spTree>
+  </p:cSld>
+  <p:clrMapOvr>
+    <a:masterClrMapping/>
+  </p:clrMapOvr>
+</p:sld>
+</file>
+
+<file path=ppt/slides/slide25.xml><?xml version="1.0" encoding="utf-8"?>
 <p:sld xmlns:a="http://schemas.openxmlformats.org/drawingml/2006/main" xmlns:p="http://schemas.openxmlformats.org/presentationml/2006/main" xmlns:r="http://schemas.openxmlformats.org/officeDocument/2006/relationships">
   <p:cSld>
     <p:bg>

</xml_diff>